<commit_message>
Publish bilingual bank evidence package
</commit_message>
<xml_diff>
--- a/site/downloads/pixan-bank-deck-large-fi.pptx
+++ b/site/downloads/pixan-bank-deck-large-fi.pptx
@@ -3386,7 +3386,7 @@
                 </a:solidFill>
                 <a:latin typeface="Aptos"/>
               </a:rPr>
-              <a:t>2026.07.22-7</a:t>
+              <a:t>2026.07.22-8</a:t>
             </a:r>
           </a:p>
         </p:txBody>
@@ -3740,7 +3740,7 @@
                 </a:solidFill>
                 <a:latin typeface="Aptos"/>
               </a:rPr>
-              <a:t>Julkinen riippumaton evidenssikooste · 2026.07.22-7 · 2026-07-22 · Lähteet: RPX; CNIPA guidance; EPO family</a:t>
+              <a:t>Julkinen riippumaton evidenssikooste · 2026.07.22-8 · 2026-07-22 · Lähteet: RPX; CNIPA guidance; EPO family</a:t>
             </a:r>
           </a:p>
         </p:txBody>
@@ -4220,7 +4220,7 @@
                 </a:solidFill>
                 <a:latin typeface="Aptos"/>
               </a:rPr>
-              <a:t>Julkinen riippumaton evidenssikooste · 2026.07.22-7 · 2026-07-22 · Lähteet: IP Australia; PRH; EPO; USPTO</a:t>
+              <a:t>Julkinen riippumaton evidenssikooste · 2026.07.22-8 · 2026-07-22 · Lähteet: IP Australia; PRH; EPO; EPO / UPC; USPTO</a:t>
             </a:r>
           </a:p>
         </p:txBody>
@@ -4420,7 +4420,7 @@
                         </a:defRPr>
                       </a:pPr>
                       <a:r>
-                        <a:t>Vahvista maksu, kuitti ja uusi rekisteriote</a:t>
+                        <a:t>Vahvista Australian seuraava uusiminen heti</a:t>
                       </a:r>
                     </a:p>
                   </a:txBody>
@@ -4494,7 +4494,7 @@
                         </a:defRPr>
                       </a:pPr>
                       <a:r>
-                        <a:t>Maksa 14. vuosimaksu ja arkistoi kuitti</a:t>
+                        <a:t>Suomen 14. vuosimaksu erääntyy</a:t>
                       </a:r>
                     </a:p>
                   </a:txBody>
@@ -4568,7 +4568,7 @@
                         </a:defRPr>
                       </a:pPr>
                       <a:r>
-                        <a:t>Täsmäytä kaikki kansalliset oikeudet</a:t>
+                        <a:t>Täsmäytä jokainen eurooppalainen kansallinen oikeus ennen maksukierrosta</a:t>
                       </a:r>
                     </a:p>
                   </a:txBody>
@@ -4642,7 +4642,7 @@
                         </a:defRPr>
                       </a:pPr>
                       <a:r>
-                        <a:t>Vahvista 7,5 vuoden ylläpitomaksu</a:t>
+                        <a:t>Vahvista ja hoida Yhdysvaltain 7,5 vuoden ylläpitomaksu</a:t>
                       </a:r>
                     </a:p>
                   </a:txBody>
@@ -4775,7 +4775,7 @@
                 </a:solidFill>
                 <a:latin typeface="Aptos"/>
               </a:rPr>
-              <a:t>Atlas kattaa maailman tutkimusrunkona, ei vielä markkina-arvona</a:t>
+              <a:t>Atlas: 195 maata (UN193+VA+PS); tutkimusrunko ei ole markkina-arvo</a:t>
             </a:r>
           </a:p>
         </p:txBody>
@@ -4900,7 +4900,7 @@
                 </a:solidFill>
                 <a:latin typeface="Aptos"/>
               </a:rPr>
-              <a:t>Julkinen riippumaton evidenssikooste · 2026.07.22-7 · 2026-07-22 · Lähteet: UN; Atlas</a:t>
+              <a:t>Julkinen riippumaton evidenssikooste · 2026.07.22-8 · 2026-07-22 · Lähteet: UN; Atlas</a:t>
             </a:r>
           </a:p>
         </p:txBody>
@@ -4949,7 +4949,7 @@
         <p:spPr>
           <a:xfrm>
             <a:off x="530352" y="1719072"/>
-            <a:ext cx="3532632" cy="1371600"/>
+            <a:ext cx="2585466" cy="1371600"/>
           </a:xfrm>
           <a:prstGeom prst="roundRect">
             <a:avLst>
@@ -4996,7 +4996,7 @@
         <p:spPr>
           <a:xfrm>
             <a:off x="694944" y="1883664"/>
-            <a:ext cx="3203448" cy="530352"/>
+            <a:ext cx="2256282" cy="530352"/>
           </a:xfrm>
           <a:prstGeom prst="rect">
             <a:avLst/>
@@ -5017,7 +5017,7 @@
                 </a:solidFill>
                 <a:latin typeface="Aptos"/>
               </a:rPr>
-              <a:t>195</a:t>
+              <a:t>5</a:t>
             </a:r>
           </a:p>
         </p:txBody>
@@ -5031,7 +5031,7 @@
         <p:spPr>
           <a:xfrm>
             <a:off x="694944" y="2468879"/>
-            <a:ext cx="3203448" cy="438912"/>
+            <a:ext cx="2256282" cy="438912"/>
           </a:xfrm>
           <a:prstGeom prst="rect">
             <a:avLst/>
@@ -5052,7 +5052,7 @@
                 </a:solidFill>
                 <a:latin typeface="Aptos"/>
               </a:rPr>
-              <a:t>maata universumissa</a:t>
+              <a:t>A-luokan maata</a:t>
             </a:r>
           </a:p>
         </p:txBody>
@@ -5065,8 +5065,8 @@
         </p:nvSpPr>
         <p:spPr>
           <a:xfrm>
-            <a:off x="4319016" y="1719072"/>
-            <a:ext cx="3532632" cy="1371600"/>
+            <a:off x="3371850" y="1719072"/>
+            <a:ext cx="2585466" cy="1371600"/>
           </a:xfrm>
           <a:prstGeom prst="roundRect">
             <a:avLst>
@@ -5112,8 +5112,8 @@
         </p:nvSpPr>
         <p:spPr>
           <a:xfrm>
-            <a:off x="4483608" y="1883664"/>
-            <a:ext cx="3203448" cy="530352"/>
+            <a:off x="3536442" y="1883664"/>
+            <a:ext cx="2256282" cy="530352"/>
           </a:xfrm>
           <a:prstGeom prst="rect">
             <a:avLst/>
@@ -5134,7 +5134,7 @@
                 </a:solidFill>
                 <a:latin typeface="Aptos"/>
               </a:rPr>
-              <a:t>37</a:t>
+              <a:t>13</a:t>
             </a:r>
           </a:p>
         </p:txBody>
@@ -5147,8 +5147,8 @@
         </p:nvSpPr>
         <p:spPr>
           <a:xfrm>
-            <a:off x="4483608" y="2468879"/>
-            <a:ext cx="3203448" cy="438912"/>
+            <a:off x="3536442" y="2468879"/>
+            <a:ext cx="2256282" cy="438912"/>
           </a:xfrm>
           <a:prstGeom prst="rect">
             <a:avLst/>
@@ -5169,7 +5169,7 @@
                 </a:solidFill>
                 <a:latin typeface="Aptos"/>
               </a:rPr>
-              <a:t>evidenssimerkintää</a:t>
+              <a:t>B-luokan maata</a:t>
             </a:r>
           </a:p>
         </p:txBody>
@@ -5182,8 +5182,8 @@
         </p:nvSpPr>
         <p:spPr>
           <a:xfrm>
-            <a:off x="8107680" y="1719072"/>
-            <a:ext cx="3532632" cy="1371600"/>
+            <a:off x="6213348" y="1719072"/>
+            <a:ext cx="2585466" cy="1371600"/>
           </a:xfrm>
           <a:prstGeom prst="roundRect">
             <a:avLst>
@@ -5229,8 +5229,8 @@
         </p:nvSpPr>
         <p:spPr>
           <a:xfrm>
-            <a:off x="8272272" y="1883664"/>
-            <a:ext cx="3203448" cy="530352"/>
+            <a:off x="6377940" y="1883664"/>
+            <a:ext cx="2256282" cy="530352"/>
           </a:xfrm>
           <a:prstGeom prst="rect">
             <a:avLst/>
@@ -5251,6 +5251,123 @@
                 </a:solidFill>
                 <a:latin typeface="Aptos"/>
               </a:rPr>
+              <a:t>19</a:t>
+            </a:r>
+          </a:p>
+        </p:txBody>
+      </p:sp>
+      <p:sp>
+        <p:nvSpPr>
+          <p:cNvPr id="16" name="TextBox 15"/>
+          <p:cNvSpPr txBox="1"/>
+          <p:nvPr/>
+        </p:nvSpPr>
+        <p:spPr>
+          <a:xfrm>
+            <a:off x="6377940" y="2468879"/>
+            <a:ext cx="2256282" cy="438912"/>
+          </a:xfrm>
+          <a:prstGeom prst="rect">
+            <a:avLst/>
+          </a:prstGeom>
+          <a:noFill/>
+        </p:spPr>
+        <p:txBody>
+          <a:bodyPr wrap="square" lIns="36576" rIns="36576" tIns="36576" bIns="36576" anchor="t">
+            <a:spAutoFit/>
+          </a:bodyPr>
+          <a:lstStyle/>
+          <a:p>
+            <a:pPr algn="l"/>
+            <a:r>
+              <a:rPr sz="1400" b="0">
+                <a:solidFill>
+                  <a:srgbClr val="5B6B75"/>
+                </a:solidFill>
+                <a:latin typeface="Aptos"/>
+              </a:rPr>
+              <a:t>C-luokan maata</a:t>
+            </a:r>
+          </a:p>
+        </p:txBody>
+      </p:sp>
+      <p:sp>
+        <p:nvSpPr>
+          <p:cNvPr id="17" name="Rounded Rectangle 16"/>
+          <p:cNvSpPr/>
+          <p:nvPr/>
+        </p:nvSpPr>
+        <p:spPr>
+          <a:xfrm>
+            <a:off x="9054846" y="1719072"/>
+            <a:ext cx="2585466" cy="1371600"/>
+          </a:xfrm>
+          <a:prstGeom prst="roundRect">
+            <a:avLst>
+              <a:gd name="adj" fmla="val 8000"/>
+            </a:avLst>
+          </a:prstGeom>
+          <a:solidFill>
+            <a:srgbClr val="F6F9FA"/>
+          </a:solidFill>
+          <a:ln>
+            <a:solidFill>
+              <a:srgbClr val="CBD8DE"/>
+            </a:solidFill>
+          </a:ln>
+        </p:spPr>
+        <p:style>
+          <a:lnRef idx="1">
+            <a:schemeClr val="accent1"/>
+          </a:lnRef>
+          <a:fillRef idx="3">
+            <a:schemeClr val="accent1"/>
+          </a:fillRef>
+          <a:effectRef idx="2">
+            <a:schemeClr val="accent1"/>
+          </a:effectRef>
+          <a:fontRef idx="minor">
+            <a:schemeClr val="lt1"/>
+          </a:fontRef>
+        </p:style>
+        <p:txBody>
+          <a:bodyPr rtlCol="0" anchor="ctr"/>
+          <a:lstStyle/>
+          <a:p>
+            <a:pPr algn="ctr"/>
+          </a:p>
+        </p:txBody>
+      </p:sp>
+      <p:sp>
+        <p:nvSpPr>
+          <p:cNvPr id="18" name="TextBox 17"/>
+          <p:cNvSpPr txBox="1"/>
+          <p:nvPr/>
+        </p:nvSpPr>
+        <p:spPr>
+          <a:xfrm>
+            <a:off x="9219438" y="1883664"/>
+            <a:ext cx="2256282" cy="530352"/>
+          </a:xfrm>
+          <a:prstGeom prst="rect">
+            <a:avLst/>
+          </a:prstGeom>
+          <a:noFill/>
+        </p:spPr>
+        <p:txBody>
+          <a:bodyPr wrap="square" lIns="36576" rIns="36576" tIns="36576" bIns="36576" anchor="t">
+            <a:spAutoFit/>
+          </a:bodyPr>
+          <a:lstStyle/>
+          <a:p>
+            <a:pPr algn="l"/>
+            <a:r>
+              <a:rPr sz="2700" b="1">
+                <a:solidFill>
+                  <a:srgbClr val="138A72"/>
+                </a:solidFill>
+                <a:latin typeface="Aptos"/>
+              </a:rPr>
               <a:t>158</a:t>
             </a:r>
           </a:p>
@@ -5258,14 +5375,14 @@
       </p:sp>
       <p:sp>
         <p:nvSpPr>
-          <p:cNvPr id="16" name="TextBox 15"/>
-          <p:cNvSpPr txBox="1"/>
-          <p:nvPr/>
-        </p:nvSpPr>
-        <p:spPr>
-          <a:xfrm>
-            <a:off x="8272272" y="2468879"/>
-            <a:ext cx="3203448" cy="438912"/>
+          <p:cNvPr id="19" name="TextBox 18"/>
+          <p:cNvSpPr txBox="1"/>
+          <p:nvPr/>
+        </p:nvSpPr>
+        <p:spPr>
+          <a:xfrm>
+            <a:off x="9219438" y="2468879"/>
+            <a:ext cx="2256282" cy="438912"/>
           </a:xfrm>
           <a:prstGeom prst="rect">
             <a:avLst/>
@@ -5293,7 +5410,7 @@
       </p:sp>
       <p:sp>
         <p:nvSpPr>
-          <p:cNvPr id="17" name="TextBox 16"/>
+          <p:cNvPr id="20" name="TextBox 19"/>
           <p:cNvSpPr txBox="1"/>
           <p:nvPr/>
         </p:nvSpPr>
@@ -5321,14 +5438,14 @@
                 </a:solidFill>
                 <a:latin typeface="Aptos"/>
               </a:rPr>
-              <a:t>Kattavuus tarkoittaa tutkimusrivejä; useimmista maista puuttuu virallinen vuosimyynti.</a:t>
-            </a:r>
-          </a:p>
-        </p:txBody>
-      </p:sp>
-      <p:sp>
-        <p:nvSpPr>
-          <p:cNvPr id="18" name="Rounded Rectangle 17"/>
+              <a:t>37 evidenssimerkintää; universumin YK-osuus on 193 jäsenvaltiota.</a:t>
+            </a:r>
+          </a:p>
+        </p:txBody>
+      </p:sp>
+      <p:sp>
+        <p:nvSpPr>
+          <p:cNvPr id="21" name="Rounded Rectangle 20"/>
           <p:cNvSpPr/>
           <p:nvPr/>
         </p:nvSpPr>
@@ -5375,7 +5492,7 @@
       </p:sp>
       <p:sp>
         <p:nvSpPr>
-          <p:cNvPr id="19" name="TextBox 18"/>
+          <p:cNvPr id="22" name="TextBox 21"/>
           <p:cNvSpPr txBox="1"/>
           <p:nvPr/>
         </p:nvSpPr>
@@ -5410,7 +5527,7 @@
       </p:sp>
       <p:sp>
         <p:nvSpPr>
-          <p:cNvPr id="20" name="TextBox 19"/>
+          <p:cNvPr id="23" name="TextBox 22"/>
           <p:cNvSpPr txBox="1"/>
           <p:nvPr/>
         </p:nvSpPr>
@@ -5526,7 +5643,7 @@
                 </a:solidFill>
                 <a:latin typeface="Aptos"/>
               </a:rPr>
-              <a:t>Viiden maan viralliset havainnot mittaavat eri asioita</a:t>
+              <a:t>Viralliset havainnot 5 maasta mittaavat eri asioita</a:t>
             </a:r>
           </a:p>
         </p:txBody>
@@ -5651,7 +5768,7 @@
                 </a:solidFill>
                 <a:latin typeface="Aptos"/>
               </a:rPr>
-              <a:t>Julkinen riippumaton evidenssikooste · 2026.07.22-7 · 2026-07-22 · Lähteet: Health Canada; Destatis; Vero; Sejm; Ruotsin hallitus</a:t>
+              <a:t>Julkinen riippumaton evidenssikooste · 2026.07.22-8 · 2026-07-22 · Lähteet: Health Canada; Destatis; Vero; Sejm; Ruotsin hallitus</a:t>
             </a:r>
           </a:p>
         </p:txBody>
@@ -5851,7 +5968,7 @@
                         </a:defRPr>
                       </a:pPr>
                       <a:r>
-                        <a:t>1.16 mrd CAD toimitusarvo; 1.252 milj. l nestettä</a:t>
+                        <a:t>1,16 mrd CAD toimitusarvo; 1 251 843 l nestettä</a:t>
                       </a:r>
                     </a:p>
                   </a:txBody>
@@ -5925,7 +6042,7 @@
                         </a:defRPr>
                       </a:pPr>
                       <a:r>
-                        <a:t>1.241 milj. l → 1.518 milj. l verotettua nestettä</a:t>
+                        <a:t>1,241 milj. l → 1,518 milj. l verotettua nestettä</a:t>
                       </a:r>
                     </a:p>
                   </a:txBody>
@@ -5999,7 +6116,7 @@
                         </a:defRPr>
                       </a:pPr>
                       <a:r>
-                        <a:t>11 801,062 l; 3,540 milj. € valmisteveroa</a:t>
+                        <a:t>11 801,062 l; 3,54 milj. EUR valmisteveroa</a:t>
                       </a:r>
                     </a:p>
                   </a:txBody>
@@ -6073,7 +6190,7 @@
                         </a:defRPr>
                       </a:pPr>
                       <a:r>
-                        <a:t>805 441 l; 993,1 milj. PLN e-nesteveroa</a:t>
+                        <a:t>805 441 l; 993,1 milj. PLN valmisteveroa</a:t>
                       </a:r>
                     </a:p>
                   </a:txBody>
@@ -6405,7 +6522,7 @@
                 </a:solidFill>
                 <a:latin typeface="Aptos"/>
               </a:rPr>
-              <a:t>Julkinen riippumaton evidenssikooste · 2026.07.22-7 · 2026-07-22 · Lähteet: Health Canada 2024</a:t>
+              <a:t>Julkinen riippumaton evidenssikooste · 2026.07.22-8 · 2026-07-22 · Lähteet: Health Canada 2024</a:t>
             </a:r>
           </a:p>
         </p:txBody>
@@ -6522,7 +6639,7 @@
                 </a:solidFill>
                 <a:latin typeface="Aptos"/>
               </a:rPr>
-              <a:t>1.16 mrd CAD</a:t>
+              <a:t>1,16 mrd CAD</a:t>
             </a:r>
           </a:p>
         </p:txBody>
@@ -6639,7 +6756,7 @@
                 </a:solidFill>
                 <a:latin typeface="Aptos"/>
               </a:rPr>
-              <a:t>118,9 milj.</a:t>
+              <a:t>118,9 milj. yks.</a:t>
             </a:r>
           </a:p>
         </p:txBody>
@@ -6674,7 +6791,7 @@
                 </a:solidFill>
                 <a:latin typeface="Aptos"/>
               </a:rPr>
-              <a:t>raportoitua yksikköä</a:t>
+              <a:t>raportoitua yksikkömäärää</a:t>
             </a:r>
           </a:p>
         </p:txBody>
@@ -6756,7 +6873,7 @@
                 </a:solidFill>
                 <a:latin typeface="Aptos"/>
               </a:rPr>
-              <a:t>1.252 milj. l</a:t>
+              <a:t>1,252 milj. l</a:t>
             </a:r>
           </a:p>
         </p:txBody>
@@ -6826,7 +6943,7 @@
                 </a:solidFill>
                 <a:latin typeface="Aptos"/>
               </a:rPr>
-              <a:t>Virallinen koko vuoden havainto kattaa neljä vaping-tuoteryhmää.</a:t>
+              <a:t>Virallinen koko vuoden toimitusarvo tukku- tai vähittäismyyjille kaikissa neljässä raportoidussa tuoteryhmässä.</a:t>
             </a:r>
           </a:p>
         </p:txBody>
@@ -6943,7 +7060,7 @@
                 </a:solidFill>
                 <a:latin typeface="Aptos"/>
               </a:rPr>
-              <a:t>Tukku-/vähittäismyyjille toimitettu arvo ei ole kuluttajien kassamyynti; varasto, kate ja kanava on täsmäytettävä.</a:t>
+              <a:t>Virallinen koko vuoden toimitusarvo tukku- tai vähittäismyyjille kaikissa neljässä raportoidussa tuoteryhmässä. Kyse ei ole kuluttajien vähittäisostoista, ja Health Canada voi tarkistaa tietoa.</a:t>
             </a:r>
           </a:p>
         </p:txBody>
@@ -7156,7 +7273,7 @@
                 </a:solidFill>
                 <a:latin typeface="Aptos"/>
               </a:rPr>
-              <a:t>Julkinen riippumaton evidenssikooste · 2026.07.22-7 · 2026-07-22 · Lähteet: Destatis 73411-0003</a:t>
+              <a:t>Julkinen riippumaton evidenssikooste · 2026.07.22-8 · 2026-07-22 · Lähteet: Destatis</a:t>
             </a:r>
           </a:p>
         </p:txBody>
@@ -7357,7 +7474,7 @@
                         </a:defRPr>
                       </a:pPr>
                       <a:r>
-                        <a:t>1.241 milj. l</a:t>
+                        <a:t>1,241 milj. l</a:t>
                       </a:r>
                     </a:p>
                   </a:txBody>
@@ -7381,7 +7498,7 @@
                         </a:defRPr>
                       </a:pPr>
                       <a:r>
-                        <a:t>201 milj. €</a:t>
+                        <a:t>201 milj. EUR</a:t>
                       </a:r>
                     </a:p>
                   </a:txBody>
@@ -7455,7 +7572,7 @@
                         </a:defRPr>
                       </a:pPr>
                       <a:r>
-                        <a:t>1.284 milj. l</a:t>
+                        <a:t>1,284 milj. l</a:t>
                       </a:r>
                     </a:p>
                   </a:txBody>
@@ -7479,7 +7596,7 @@
                         </a:defRPr>
                       </a:pPr>
                       <a:r>
-                        <a:t>266 milj. €</a:t>
+                        <a:t>266 milj. EUR</a:t>
                       </a:r>
                     </a:p>
                   </a:txBody>
@@ -7553,7 +7670,7 @@
                         </a:defRPr>
                       </a:pPr>
                       <a:r>
-                        <a:t>1.518 milj. l</a:t>
+                        <a:t>1,518 milj. l</a:t>
                       </a:r>
                     </a:p>
                   </a:txBody>
@@ -7577,7 +7694,7 @@
                         </a:defRPr>
                       </a:pPr>
                       <a:r>
-                        <a:t>404 milj. €</a:t>
+                        <a:t>404 milj. EUR</a:t>
                       </a:r>
                     </a:p>
                   </a:txBody>
@@ -7859,7 +7976,7 @@
                 </a:solidFill>
                 <a:latin typeface="Aptos"/>
               </a:rPr>
-              <a:t>Julkinen riippumaton evidenssikooste · 2026.07.22-7 · 2026-07-22 · Lähteet: Destatis; inTaste-hintapisteet</a:t>
+              <a:t>Julkinen riippumaton evidenssikooste · 2026.07.22-8 · 2026-07-22 · Lähteet: Destatis; inTaste.de</a:t>
             </a:r>
           </a:p>
         </p:txBody>
@@ -7976,7 +8093,7 @@
                 </a:solidFill>
                 <a:latin typeface="Aptos"/>
               </a:rPr>
-              <a:t>667.9 M€</a:t>
+              <a:t>667,92 milj. EUR</a:t>
             </a:r>
           </a:p>
         </p:txBody>
@@ -8011,7 +8128,7 @@
                 </a:solidFill>
                 <a:latin typeface="Aptos"/>
               </a:rPr>
-              <a:t>0,44 €/ml</a:t>
+              <a:t>0,44 EUR/ml</a:t>
             </a:r>
           </a:p>
         </p:txBody>
@@ -8093,7 +8210,7 @@
                 </a:solidFill>
                 <a:latin typeface="Aptos"/>
               </a:rPr>
-              <a:t>1 199.2 M€</a:t>
+              <a:t>1 199,22 milj. EUR</a:t>
             </a:r>
           </a:p>
         </p:txBody>
@@ -8128,7 +8245,7 @@
                 </a:solidFill>
                 <a:latin typeface="Aptos"/>
               </a:rPr>
-              <a:t>0,79 €/ml</a:t>
+              <a:t>0,79 EUR/ml</a:t>
             </a:r>
           </a:p>
         </p:txBody>
@@ -8210,7 +8327,7 @@
                 </a:solidFill>
                 <a:latin typeface="Aptos"/>
               </a:rPr>
-              <a:t>1 654.6 M€</a:t>
+              <a:t>1 654,62 milj. EUR</a:t>
             </a:r>
           </a:p>
         </p:txBody>
@@ -8245,7 +8362,7 @@
                 </a:solidFill>
                 <a:latin typeface="Aptos"/>
               </a:rPr>
-              <a:t>1,09 €/ml</a:t>
+              <a:t>1,09 EUR/ml</a:t>
             </a:r>
           </a:p>
         </p:txBody>
@@ -8397,7 +8514,7 @@
                 </a:solidFill>
                 <a:latin typeface="Aptos"/>
               </a:rPr>
-              <a:t>Vuoden 2025 alustava määrä kerrotaan kolmella yhden verkkokaupan vuoden 2026 hinnalla. Confidence = low; laitteet ja useita kanava-/mix-tekijöitä puuttuu.</a:t>
+              <a:t>Ei havaittua myyntiä. Laskelma kertoo vuoden 2025 alustavan verotetun nestemäärän kolmella yksittäisellä saksalaisen verkkokaupan vuoden 2026 hinnalla. Vuosiero, yhden kaupan hintakori, tuotejakauma ja pois rajatut tuoteryhmät tekevät luottamustasosta matalan.</a:t>
             </a:r>
           </a:p>
         </p:txBody>
@@ -8610,7 +8727,7 @@
                 </a:solidFill>
                 <a:latin typeface="Aptos"/>
               </a:rPr>
-              <a:t>Julkinen riippumaton evidenssikooste · 2026.07.22-7 · 2026-07-22 · Lähteet: IMARC; Grand View Research; Fortune Business Insights</a:t>
+              <a:t>Julkinen riippumaton evidenssikooste · 2026.07.22-8 · 2026-07-22 · Lähteet: IMARC; GVR; Fortune</a:t>
             </a:r>
           </a:p>
         </p:txBody>
@@ -8727,7 +8844,7 @@
                 </a:solidFill>
                 <a:latin typeface="Aptos"/>
               </a:rPr>
-              <a:t>$26,0 mrd</a:t>
+              <a:t>26,0 mrd USD</a:t>
             </a:r>
           </a:p>
         </p:txBody>
@@ -8844,7 +8961,7 @@
                 </a:solidFill>
                 <a:latin typeface="Aptos"/>
               </a:rPr>
-              <a:t>$45,7 mrd</a:t>
+              <a:t>45,7 mrd USD</a:t>
             </a:r>
           </a:p>
         </p:txBody>
@@ -8961,7 +9078,7 @@
                 </a:solidFill>
                 <a:latin typeface="Aptos"/>
               </a:rPr>
-              <a:t>$46,32 mrd</a:t>
+              <a:t>46,32 mrd USD</a:t>
             </a:r>
           </a:p>
         </p:txBody>
@@ -9236,7 +9353,7 @@
                 </a:solidFill>
                 <a:latin typeface="Aptos"/>
               </a:rPr>
-              <a:t>Hyväksyttävä maailmanestimaatti tarvitsee vähintään kolme yhteensopivaa luovuttajaa</a:t>
+              <a:t>Hyväksyttävä maailmanestimaatti tarvitsee vähintään 3 yhteensopivaa luovuttajaa</a:t>
             </a:r>
           </a:p>
         </p:txBody>
@@ -9361,7 +9478,7 @@
                 </a:solidFill>
                 <a:latin typeface="Aptos"/>
               </a:rPr>
-              <a:t>Julkinen riippumaton evidenssikooste · 2026.07.22-7 · 2026-07-22 · Lähteet: Market-values modelReadiness</a:t>
+              <a:t>Julkinen riippumaton evidenssikooste · 2026.07.22-8 · 2026-07-22 · Lähteet: Market-values modelReadiness</a:t>
             </a:r>
           </a:p>
         </p:txBody>
@@ -9841,7 +9958,7 @@
                 </a:solidFill>
                 <a:latin typeface="Aptos"/>
               </a:rPr>
-              <a:t>Julkinen riippumaton evidenssikooste · 2026.07.22-7 · 2026-07-22 · Lähteet: WIPO valuation; Evidence Register</a:t>
+              <a:t>Julkinen riippumaton evidenssikooste · 2026.07.22-8 · 2026-07-22 · Lähteet: WIPO valuation; Evidence Register</a:t>
             </a:r>
           </a:p>
         </p:txBody>
@@ -10189,7 +10306,7 @@
                         </a:defRPr>
                       </a:pPr>
                       <a:r>
-                        <a:t>Rajattu Saksan näyttö</a:t>
+                        <a:t>Rajattu näyttö: Saksa</a:t>
                       </a:r>
                     </a:p>
                   </a:txBody>
@@ -10595,7 +10712,7 @@
                 </a:solidFill>
                 <a:latin typeface="Aptos"/>
               </a:rPr>
-              <a:t>Julkinen riippumaton evidenssikooste · 2026.07.22-7 · 2026-07-22 · Lähteet: EPO; Saksan tuomiot; WIPO</a:t>
+              <a:t>Julkinen riippumaton evidenssikooste · 2026.07.22-8 · 2026-07-22 · Lähteet: EPO; Saksa — viralliset tuomiot; WIPO</a:t>
             </a:r>
           </a:p>
         </p:txBody>
@@ -10707,7 +10824,7 @@
               </a:defRPr>
             </a:pPr>
             <a:r>
-              <a:t>•  EPO:n muutettu B2-patentti ja Saksan ratkaisut muodostavat harvinaisen vahvan oikeusnäytön ankkurin.</a:t>
+              <a:t>•  EPO:n muutettu EP3032975B2 ja Saksan kaksi virallista ratkaisua muodostavat oikeusnäytön ankkurin.</a:t>
             </a:r>
           </a:p>
           <a:p>
@@ -10726,7 +10843,7 @@
               </a:defRPr>
             </a:pPr>
             <a:r>
-              <a:t>•  Markkina-aineisto kattaa 195 maan tutkimusrungon, mutta yhteismitallista vähittäisarvoa ei vielä ole.</a:t>
+              <a:t>•  Markkina-aineisto kattaa 195 maan tutkimusrungon, mutta yhteismitallisia retail-luovuttajia on 0.</a:t>
             </a:r>
           </a:p>
           <a:p>
@@ -11075,7 +11192,7 @@
                 </a:solidFill>
                 <a:latin typeface="Aptos"/>
               </a:rPr>
-              <a:t>Julkinen riippumaton evidenssikooste · 2026.07.22-7 · 2026-07-22 · Lähteet: WIPO licensing; IP Finance</a:t>
+              <a:t>Julkinen riippumaton evidenssikooste · 2026.07.22-8 · 2026-07-22 · Lähteet: WIPO licensing; IP Finance</a:t>
             </a:r>
           </a:p>
         </p:txBody>
@@ -11555,7 +11672,7 @@
                 </a:solidFill>
                 <a:latin typeface="Aptos"/>
               </a:rPr>
-              <a:t>Julkinen riippumaton evidenssikooste · 2026.07.22-7 · 2026-07-22 · Lähteet: Evidence Register; EPO</a:t>
+              <a:t>Julkinen riippumaton evidenssikooste · 2026.07.22-8 · 2026-07-22 · Lähteet: Evidence Register; EPO</a:t>
             </a:r>
           </a:p>
         </p:txBody>
@@ -12235,7 +12352,7 @@
                 </a:solidFill>
                 <a:latin typeface="Aptos"/>
               </a:rPr>
-              <a:t>Julkinen riippumaton evidenssikooste · 2026.07.22-7 · 2026-07-22 · Lähteet: EP3032975B2; Saksan tuomio</a:t>
+              <a:t>Julkinen riippumaton evidenssikooste · 2026.07.22-8 · 2026-07-22 · Lähteet: EP3032975B2; 7 O 3341/24</a:t>
             </a:r>
           </a:p>
         </p:txBody>
@@ -13126,7 +13243,7 @@
                 </a:solidFill>
                 <a:latin typeface="Aptos"/>
               </a:rPr>
-              <a:t>Julkinen riippumaton evidenssikooste · 2026.07.22-7 · 2026-07-22 · Lähteet: WIPO dispute resolution; EPO IPscore</a:t>
+              <a:t>Julkinen riippumaton evidenssikooste · 2026.07.22-8 · 2026-07-22 · Lähteet: WIPO dispute resolution; EPO IPscore</a:t>
             </a:r>
           </a:p>
         </p:txBody>
@@ -14017,7 +14134,7 @@
                 </a:solidFill>
                 <a:latin typeface="Aptos"/>
               </a:rPr>
-              <a:t>Julkinen riippumaton evidenssikooste · 2026.07.22-7 · 2026-07-22 · Lähteet: WIPO licensing; IP Finance; TPLF mapping</a:t>
+              <a:t>Julkinen riippumaton evidenssikooste · 2026.07.22-8 · 2026-07-22 · Lähteet: WIPO licensing; IP Finance; TPLF mapping</a:t>
             </a:r>
           </a:p>
         </p:txBody>
@@ -14771,7 +14888,7 @@
                 </a:solidFill>
                 <a:latin typeface="Aptos"/>
               </a:rPr>
-              <a:t>Julkinen riippumaton evidenssikooste · 2026.07.22-7 · 2026-07-22 · Lähteet: Evidence Register; WIPO valuation</a:t>
+              <a:t>Julkinen riippumaton evidenssikooste · 2026.07.22-8 · 2026-07-22 · Lähteet: Evidence Register; WIPO valuation</a:t>
             </a:r>
           </a:p>
         </p:txBody>
@@ -15599,7 +15716,7 @@
                 </a:solidFill>
                 <a:latin typeface="Aptos"/>
               </a:rPr>
-              <a:t>Julkinen riippumaton evidenssikooste · 2026.07.22-7 · 2026-07-22 · Lähteet: WIPO valuation</a:t>
+              <a:t>Julkinen riippumaton evidenssikooste · 2026.07.22-8 · 2026-07-22 · Lähteet: WIPO valuation</a:t>
             </a:r>
           </a:p>
         </p:txBody>
@@ -16498,7 +16615,7 @@
                 </a:solidFill>
                 <a:latin typeface="Aptos"/>
               </a:rPr>
-              <a:t>Julkinen riippumaton evidenssikooste · 2026.07.22-7 · 2026-07-22 · Lähteet: Evidence Register</a:t>
+              <a:t>Julkinen riippumaton evidenssikooste · 2026.07.22-8 · 2026-07-22 · Lähteet: Evidence Register</a:t>
             </a:r>
           </a:p>
         </p:txBody>
@@ -17252,7 +17369,7 @@
                 </a:solidFill>
                 <a:latin typeface="Aptos"/>
               </a:rPr>
-              <a:t>Julkinen riippumaton evidenssikooste · 2026.07.22-7 · 2026-07-22 · Lähteet: Evidence Register</a:t>
+              <a:t>Julkinen riippumaton evidenssikooste · 2026.07.22-8 · 2026-07-22 · Lähteet: Evidence Register</a:t>
             </a:r>
           </a:p>
         </p:txBody>
@@ -18080,7 +18197,7 @@
                 </a:solidFill>
                 <a:latin typeface="Aptos"/>
               </a:rPr>
-              <a:t>Julkinen riippumaton evidenssikooste · 2026.07.22-7 · 2026-07-22 · Lähteet: Evidence Register; changelog</a:t>
+              <a:t>Julkinen riippumaton evidenssikooste · 2026.07.22-8 · 2026-07-22 · Lähteet: Evidence Register; changelog</a:t>
             </a:r>
           </a:p>
         </p:txBody>
@@ -18971,7 +19088,7 @@
                 </a:solidFill>
                 <a:latin typeface="Aptos"/>
               </a:rPr>
-              <a:t>Julkinen riippumaton evidenssikooste · 2026.07.22-7 · 2026-07-22 · Lähteet: EPO; DE 8 Ni 18/24; DE 7 O 3341/24</a:t>
+              <a:t>Julkinen riippumaton evidenssikooste · 2026.07.22-8 · 2026-07-22 · Lähteet: EPO; 8 Ni 18/24 (EP); 7 O 3341/24</a:t>
             </a:r>
           </a:p>
         </p:txBody>
@@ -19123,7 +19240,7 @@
                         </a:defRPr>
                       </a:pPr>
                       <a:r>
-                        <a:t>EPO pysytti patentin muutettuna</a:t>
+                        <a:t>EPO:n keskitetty riitautus päättyi patentin pysyttämiseen muutettuna</a:t>
                       </a:r>
                     </a:p>
                   </a:txBody>
@@ -19197,7 +19314,7 @@
                         </a:defRPr>
                       </a:pPr>
                       <a:r>
-                        <a:t>Saksan mitätöintiratkaisu</a:t>
+                        <a:t>Mitätöintikanne hylättiin; valitus vireillä</a:t>
                       </a:r>
                     </a:p>
                   </a:txBody>
@@ -19271,7 +19388,7 @@
                         </a:defRPr>
                       </a:pPr>
                       <a:r>
-                        <a:t>Saksan loukkausratkaisu</a:t>
+                        <a:t>Tarkasteltujen tuotteiden todettiin loukkaavan patenttia</a:t>
                       </a:r>
                     </a:p>
                   </a:txBody>
@@ -19502,7 +19619,7 @@
               </a:defRPr>
             </a:pPr>
             <a:r>
-              <a:t>•  Vahva lähtökohta: dokumentoitu patenttiydin ja virallista Saksan oikeusnäyttöä.</a:t>
+              <a:t>•  Vahva lähtökohta: dokumentoitu patenttiydin ja Saksan virallista oikeusnäyttöä.</a:t>
             </a:r>
           </a:p>
           <a:p>
@@ -19594,7 +19711,7 @@
                 </a:solidFill>
                 <a:latin typeface="Aptos"/>
               </a:rPr>
-              <a:t>Versio 2026.07.22-7 · 2026-07-22 · 30 / 30</a:t>
+              <a:t>Versio 2026.07.22-8 · 2026-07-22 · 30 / 30</a:t>
             </a:r>
           </a:p>
         </p:txBody>
@@ -19807,7 +19924,7 @@
                 </a:solidFill>
                 <a:latin typeface="Aptos"/>
               </a:rPr>
-              <a:t>Julkinen riippumaton evidenssikooste · 2026.07.22-7 · 2026-07-22 · Lähteet: Evidence Register; WIPO</a:t>
+              <a:t>Julkinen riippumaton evidenssikooste · 2026.07.22-8 · 2026-07-22 · Lähteet: Evidence Register; WIPO</a:t>
             </a:r>
           </a:p>
         </p:txBody>
@@ -19938,7 +20055,7 @@
               </a:defRPr>
             </a:pPr>
             <a:r>
-              <a:t>•  Tuote- ja myyntikytkentä on vahvistettu vain rajatusti Saksan tuomiossa.</a:t>
+              <a:t>•  Tuote- ja myyntikytkentä on vahvistettu vain rajatusti: Saksa, 7 O 3341/24.</a:t>
             </a:r>
           </a:p>
           <a:p>
@@ -20287,7 +20404,7 @@
                 </a:solidFill>
                 <a:latin typeface="Aptos"/>
               </a:rPr>
-              <a:t>Julkinen riippumaton evidenssikooste · 2026.07.22-7 · 2026-07-22 · Lähteet: EP3032975B2</a:t>
+              <a:t>Julkinen riippumaton evidenssikooste · 2026.07.22-8 · 2026-07-22 · Lähteet: EP3032975B2</a:t>
             </a:r>
           </a:p>
         </p:txBody>
@@ -20767,7 +20884,7 @@
                 </a:solidFill>
                 <a:latin typeface="Aptos"/>
               </a:rPr>
-              <a:t>Julkinen riippumaton evidenssikooste · 2026.07.22-7 · 2026-07-22 · Lähteet: EP3032975B2</a:t>
+              <a:t>Julkinen riippumaton evidenssikooste · 2026.07.22-8 · 2026-07-22 · Lähteet: EP3032975B2</a:t>
             </a:r>
           </a:p>
         </p:txBody>
@@ -21521,7 +21638,7 @@
                 </a:solidFill>
                 <a:latin typeface="Aptos"/>
               </a:rPr>
-              <a:t>Julkinen riippumaton evidenssikooste · 2026.07.22-7 · 2026-07-22 · Lähteet: EPO Register; B2</a:t>
+              <a:t>Julkinen riippumaton evidenssikooste · 2026.07.22-8 · 2026-07-22 · Lähteet: EPO Register; B2</a:t>
             </a:r>
           </a:p>
         </p:txBody>
@@ -21942,7 +22059,7 @@
                 </a:solidFill>
                 <a:latin typeface="Aptos"/>
               </a:rPr>
-              <a:t>EPO:n keskitetty väite- ja valitusmenettely on päättynyt.</a:t>
+              <a:t>EPO:n keskitetty väite- ja valitusmenettely päättynyt; kansallinen myöntämisen jälkeinen tila on erillinen.</a:t>
             </a:r>
           </a:p>
         </p:txBody>
@@ -22272,7 +22389,7 @@
                 </a:solidFill>
                 <a:latin typeface="Aptos"/>
               </a:rPr>
-              <a:t>Julkinen riippumaton evidenssikooste · 2026.07.22-7 · 2026-07-22 · Lähteet: EPO family; kansalliset rekisterit</a:t>
+              <a:t>Julkinen riippumaton evidenssikooste · 2026.07.22-8 · 2026-07-22 · Lähteet: EPO family; kansalliset rekisterit</a:t>
             </a:r>
           </a:p>
         </p:txBody>
@@ -22321,7 +22438,7 @@
         <p:spPr>
           <a:xfrm>
             <a:off x="530352" y="1719072"/>
-            <a:ext cx="3532632" cy="1371600"/>
+            <a:ext cx="2585466" cy="1371600"/>
           </a:xfrm>
           <a:prstGeom prst="roundRect">
             <a:avLst>
@@ -22368,7 +22485,7 @@
         <p:spPr>
           <a:xfrm>
             <a:off x="694944" y="1883664"/>
-            <a:ext cx="3203448" cy="530352"/>
+            <a:ext cx="2256282" cy="530352"/>
           </a:xfrm>
           <a:prstGeom prst="rect">
             <a:avLst/>
@@ -22403,7 +22520,7 @@
         <p:spPr>
           <a:xfrm>
             <a:off x="694944" y="2468879"/>
-            <a:ext cx="3203448" cy="438912"/>
+            <a:ext cx="2256282" cy="438912"/>
           </a:xfrm>
           <a:prstGeom prst="rect">
             <a:avLst/>
@@ -22437,8 +22554,8 @@
         </p:nvSpPr>
         <p:spPr>
           <a:xfrm>
-            <a:off x="4319016" y="1719072"/>
-            <a:ext cx="3532632" cy="1371600"/>
+            <a:off x="3371850" y="1719072"/>
+            <a:ext cx="2585466" cy="1371600"/>
           </a:xfrm>
           <a:prstGeom prst="roundRect">
             <a:avLst>
@@ -22484,8 +22601,8 @@
         </p:nvSpPr>
         <p:spPr>
           <a:xfrm>
-            <a:off x="4483608" y="1883664"/>
-            <a:ext cx="3203448" cy="530352"/>
+            <a:off x="3536442" y="1883664"/>
+            <a:ext cx="2256282" cy="530352"/>
           </a:xfrm>
           <a:prstGeom prst="rect">
             <a:avLst/>
@@ -22519,8 +22636,8 @@
         </p:nvSpPr>
         <p:spPr>
           <a:xfrm>
-            <a:off x="4483608" y="2468879"/>
-            <a:ext cx="3203448" cy="438912"/>
+            <a:off x="3536442" y="2468879"/>
+            <a:ext cx="2256282" cy="438912"/>
           </a:xfrm>
           <a:prstGeom prst="rect">
             <a:avLst/>
@@ -22541,7 +22658,7 @@
                 </a:solidFill>
                 <a:latin typeface="Aptos"/>
               </a:rPr>
-              <a:t>kansallista rekisteritarkistusta</a:t>
+              <a:t>tunnistettua menettelyä</a:t>
             </a:r>
           </a:p>
         </p:txBody>
@@ -22554,8 +22671,8 @@
         </p:nvSpPr>
         <p:spPr>
           <a:xfrm>
-            <a:off x="8107680" y="1719072"/>
-            <a:ext cx="3532632" cy="1371600"/>
+            <a:off x="6213348" y="1719072"/>
+            <a:ext cx="2585466" cy="1371600"/>
           </a:xfrm>
           <a:prstGeom prst="roundRect">
             <a:avLst>
@@ -22601,8 +22718,8 @@
         </p:nvSpPr>
         <p:spPr>
           <a:xfrm>
-            <a:off x="8272272" y="1883664"/>
-            <a:ext cx="3203448" cy="530352"/>
+            <a:off x="6377940" y="1883664"/>
+            <a:ext cx="2256282" cy="530352"/>
           </a:xfrm>
           <a:prstGeom prst="rect">
             <a:avLst/>
@@ -22623,6 +22740,123 @@
                 </a:solidFill>
                 <a:latin typeface="Aptos"/>
               </a:rPr>
+              <a:t>4</a:t>
+            </a:r>
+          </a:p>
+        </p:txBody>
+      </p:sp>
+      <p:sp>
+        <p:nvSpPr>
+          <p:cNvPr id="16" name="TextBox 15"/>
+          <p:cNvSpPr txBox="1"/>
+          <p:nvPr/>
+        </p:nvSpPr>
+        <p:spPr>
+          <a:xfrm>
+            <a:off x="6377940" y="2468879"/>
+            <a:ext cx="2256282" cy="438912"/>
+          </a:xfrm>
+          <a:prstGeom prst="rect">
+            <a:avLst/>
+          </a:prstGeom>
+          <a:noFill/>
+        </p:spPr>
+        <p:txBody>
+          <a:bodyPr wrap="square" lIns="36576" rIns="36576" tIns="36576" bIns="36576" anchor="t">
+            <a:spAutoFit/>
+          </a:bodyPr>
+          <a:lstStyle/>
+          <a:p>
+            <a:pPr algn="l"/>
+            <a:r>
+              <a:rPr sz="1400" b="0">
+                <a:solidFill>
+                  <a:srgbClr val="5B6B75"/>
+                </a:solidFill>
+                <a:latin typeface="Aptos"/>
+              </a:rPr>
+              <a:t>virallista kansallista rekisteritarkistusta</a:t>
+            </a:r>
+          </a:p>
+        </p:txBody>
+      </p:sp>
+      <p:sp>
+        <p:nvSpPr>
+          <p:cNvPr id="17" name="Rounded Rectangle 16"/>
+          <p:cNvSpPr/>
+          <p:nvPr/>
+        </p:nvSpPr>
+        <p:spPr>
+          <a:xfrm>
+            <a:off x="9054846" y="1719072"/>
+            <a:ext cx="2585466" cy="1371600"/>
+          </a:xfrm>
+          <a:prstGeom prst="roundRect">
+            <a:avLst>
+              <a:gd name="adj" fmla="val 8000"/>
+            </a:avLst>
+          </a:prstGeom>
+          <a:solidFill>
+            <a:srgbClr val="F6F9FA"/>
+          </a:solidFill>
+          <a:ln>
+            <a:solidFill>
+              <a:srgbClr val="CBD8DE"/>
+            </a:solidFill>
+          </a:ln>
+        </p:spPr>
+        <p:style>
+          <a:lnRef idx="1">
+            <a:schemeClr val="accent1"/>
+          </a:lnRef>
+          <a:fillRef idx="3">
+            <a:schemeClr val="accent1"/>
+          </a:fillRef>
+          <a:effectRef idx="2">
+            <a:schemeClr val="accent1"/>
+          </a:effectRef>
+          <a:fontRef idx="minor">
+            <a:schemeClr val="lt1"/>
+          </a:fontRef>
+        </p:style>
+        <p:txBody>
+          <a:bodyPr rtlCol="0" anchor="ctr"/>
+          <a:lstStyle/>
+          <a:p>
+            <a:pPr algn="ctr"/>
+          </a:p>
+        </p:txBody>
+      </p:sp>
+      <p:sp>
+        <p:nvSpPr>
+          <p:cNvPr id="18" name="TextBox 17"/>
+          <p:cNvSpPr txBox="1"/>
+          <p:nvPr/>
+        </p:nvSpPr>
+        <p:spPr>
+          <a:xfrm>
+            <a:off x="9219438" y="1883664"/>
+            <a:ext cx="2256282" cy="530352"/>
+          </a:xfrm>
+          <a:prstGeom prst="rect">
+            <a:avLst/>
+          </a:prstGeom>
+          <a:noFill/>
+        </p:spPr>
+        <p:txBody>
+          <a:bodyPr wrap="square" lIns="36576" rIns="36576" tIns="36576" bIns="36576" anchor="t">
+            <a:spAutoFit/>
+          </a:bodyPr>
+          <a:lstStyle/>
+          <a:p>
+            <a:pPr algn="l"/>
+            <a:r>
+              <a:rPr sz="2700" b="1">
+                <a:solidFill>
+                  <a:srgbClr val="138A72"/>
+                </a:solidFill>
+                <a:latin typeface="Aptos"/>
+              </a:rPr>
               <a:t>?</a:t>
             </a:r>
           </a:p>
@@ -22630,14 +22864,14 @@
       </p:sp>
       <p:sp>
         <p:nvSpPr>
-          <p:cNvPr id="16" name="TextBox 15"/>
-          <p:cNvSpPr txBox="1"/>
-          <p:nvPr/>
-        </p:nvSpPr>
-        <p:spPr>
-          <a:xfrm>
-            <a:off x="8272272" y="2468879"/>
-            <a:ext cx="3203448" cy="438912"/>
+          <p:cNvPr id="19" name="TextBox 18"/>
+          <p:cNvSpPr txBox="1"/>
+          <p:nvPr/>
+        </p:nvSpPr>
+        <p:spPr>
+          <a:xfrm>
+            <a:off x="9219438" y="2468879"/>
+            <a:ext cx="2256282" cy="438912"/>
           </a:xfrm>
           <a:prstGeom prst="rect">
             <a:avLst/>
@@ -22665,7 +22899,7 @@
       </p:sp>
       <p:sp>
         <p:nvSpPr>
-          <p:cNvPr id="17" name="TextBox 16"/>
+          <p:cNvPr id="20" name="TextBox 19"/>
           <p:cNvSpPr txBox="1"/>
           <p:nvPr/>
         </p:nvSpPr>
@@ -22700,7 +22934,7 @@
       </p:sp>
       <p:sp>
         <p:nvSpPr>
-          <p:cNvPr id="18" name="Rounded Rectangle 17"/>
+          <p:cNvPr id="21" name="Rounded Rectangle 20"/>
           <p:cNvSpPr/>
           <p:nvPr/>
         </p:nvSpPr>
@@ -22747,7 +22981,7 @@
       </p:sp>
       <p:sp>
         <p:nvSpPr>
-          <p:cNvPr id="19" name="TextBox 18"/>
+          <p:cNvPr id="22" name="TextBox 21"/>
           <p:cNvSpPr txBox="1"/>
           <p:nvPr/>
         </p:nvSpPr>
@@ -22782,7 +23016,7 @@
       </p:sp>
       <p:sp>
         <p:nvSpPr>
-          <p:cNvPr id="20" name="TextBox 19"/>
+          <p:cNvPr id="23" name="TextBox 22"/>
           <p:cNvSpPr txBox="1"/>
           <p:nvPr/>
         </p:nvSpPr>
@@ -23023,7 +23257,7 @@
                 </a:solidFill>
                 <a:latin typeface="Aptos"/>
               </a:rPr>
-              <a:t>Julkinen riippumaton evidenssikooste · 2026.07.22-7 · 2026-07-22 · Lähteet: Viralliset Saksan tuomiot</a:t>
+              <a:t>Julkinen riippumaton evidenssikooste · 2026.07.22-8 · 2026-07-22 · Lähteet: Viralliset tuomiot: 8 Ni 18/24 (EP); 7 O 3341/24</a:t>
             </a:r>
           </a:p>
         </p:txBody>
@@ -23101,7 +23335,7 @@
                         </a:defRPr>
                       </a:pPr>
                       <a:r>
-                        <a:t>Ratkaisu</a:t>
+                        <a:t>Viite</a:t>
                       </a:r>
                     </a:p>
                   </a:txBody>
@@ -23125,7 +23359,7 @@
                         </a:defRPr>
                       </a:pPr>
                       <a:r>
-                        <a:t>Vahvistettu</a:t>
+                        <a:t>Virallinen tapahtuma</a:t>
                       </a:r>
                     </a:p>
                   </a:txBody>
@@ -23149,7 +23383,7 @@
                         </a:defRPr>
                       </a:pPr>
                       <a:r>
-                        <a:t>Avoin</a:t>
+                        <a:t>Rajaus ja lopullisuus</a:t>
                       </a:r>
                     </a:p>
                   </a:txBody>
@@ -23199,7 +23433,7 @@
                         </a:defRPr>
                       </a:pPr>
                       <a:r>
-                        <a:t>Mitätöintikanne hylättiin 14.1.2026</a:t>
+                        <a:t>Mitätöintikanne hylättiin; valitus vireillä (14.1.2026)</a:t>
                       </a:r>
                     </a:p>
                   </a:txBody>
@@ -23223,7 +23457,7 @@
                         </a:defRPr>
                       </a:pPr>
                       <a:r>
-                        <a:t>BGH-valitus X ZR 21/26</a:t>
+                        <a:t>Virallinen tuomio hylkäsi EP3032975B2:n Saksan osaa koskevan mitättömyyskanteen. Virallinen rekisteri mainitsee valituksen liittovaltion ylimpään tuomioistuimeen asianumerolla X ZR 21/26. Ei lainvoimainen BGH-valituksen ollessa vireillä.</a:t>
                       </a:r>
                     </a:p>
                   </a:txBody>
@@ -23273,7 +23507,7 @@
                         </a:defRPr>
                       </a:pPr>
                       <a:r>
-                        <a:t>Vaatimusten 1 ja 6 loukkaus tarkastelluissa tuotteissa</a:t>
+                        <a:t>Tarkasteltujen tuotteiden todettiin loukkaavan patenttia (2.4.2026)</a:t>
                       </a:r>
                     </a:p>
                   </a:txBody>
@@ -23297,7 +23531,7 @@
                         </a:defRPr>
                       </a:pPr>
                       <a:r>
-                        <a:t>Valitustila, lainvoima, täytäntöönpano, maksu</a:t>
+                        <a:t>Virallinen tuomio katsoi tarkasteltujen tuotteiden loukkaavan vaatimuksia 1 ja 6 välittömästi ja täydentävien osien osalta välillisesti sekä määräsi tuomiossa luetellut oikeusseuraamukset. Virallinen tuomio on saatavilla; valitustilaa, lainvoimaisuutta ja täytäntöönpanoa ei ole tässä julkaisussa riippumattomasti vahvistettu.</a:t>
                       </a:r>
                     </a:p>
                   </a:txBody>

</xml_diff>

<commit_message>
Publish bilingual bank evidence package (#6)
Release bilingual 6/12/30-slide diligence decks, Evidence Registers, draft-only official-data request programme, browser integrity verification and privacy hardening.
</commit_message>
<xml_diff>
--- a/site/downloads/pixan-bank-deck-large-fi.pptx
+++ b/site/downloads/pixan-bank-deck-large-fi.pptx
@@ -3386,7 +3386,7 @@
                 </a:solidFill>
                 <a:latin typeface="Aptos"/>
               </a:rPr>
-              <a:t>2026.07.22-7</a:t>
+              <a:t>2026.07.22-8</a:t>
             </a:r>
           </a:p>
         </p:txBody>
@@ -3740,7 +3740,7 @@
                 </a:solidFill>
                 <a:latin typeface="Aptos"/>
               </a:rPr>
-              <a:t>Julkinen riippumaton evidenssikooste · 2026.07.22-7 · 2026-07-22 · Lähteet: RPX; CNIPA guidance; EPO family</a:t>
+              <a:t>Julkinen riippumaton evidenssikooste · 2026.07.22-8 · 2026-07-22 · Lähteet: RPX; CNIPA guidance; EPO family</a:t>
             </a:r>
           </a:p>
         </p:txBody>
@@ -4220,7 +4220,7 @@
                 </a:solidFill>
                 <a:latin typeface="Aptos"/>
               </a:rPr>
-              <a:t>Julkinen riippumaton evidenssikooste · 2026.07.22-7 · 2026-07-22 · Lähteet: IP Australia; PRH; EPO; USPTO</a:t>
+              <a:t>Julkinen riippumaton evidenssikooste · 2026.07.22-8 · 2026-07-22 · Lähteet: IP Australia; PRH; EPO; EPO / UPC; USPTO</a:t>
             </a:r>
           </a:p>
         </p:txBody>
@@ -4420,7 +4420,7 @@
                         </a:defRPr>
                       </a:pPr>
                       <a:r>
-                        <a:t>Vahvista maksu, kuitti ja uusi rekisteriote</a:t>
+                        <a:t>Vahvista Australian seuraava uusiminen heti</a:t>
                       </a:r>
                     </a:p>
                   </a:txBody>
@@ -4494,7 +4494,7 @@
                         </a:defRPr>
                       </a:pPr>
                       <a:r>
-                        <a:t>Maksa 14. vuosimaksu ja arkistoi kuitti</a:t>
+                        <a:t>Suomen 14. vuosimaksu erääntyy</a:t>
                       </a:r>
                     </a:p>
                   </a:txBody>
@@ -4568,7 +4568,7 @@
                         </a:defRPr>
                       </a:pPr>
                       <a:r>
-                        <a:t>Täsmäytä kaikki kansalliset oikeudet</a:t>
+                        <a:t>Täsmäytä jokainen eurooppalainen kansallinen oikeus ennen maksukierrosta</a:t>
                       </a:r>
                     </a:p>
                   </a:txBody>
@@ -4642,7 +4642,7 @@
                         </a:defRPr>
                       </a:pPr>
                       <a:r>
-                        <a:t>Vahvista 7,5 vuoden ylläpitomaksu</a:t>
+                        <a:t>Vahvista ja hoida Yhdysvaltain 7,5 vuoden ylläpitomaksu</a:t>
                       </a:r>
                     </a:p>
                   </a:txBody>
@@ -4775,7 +4775,7 @@
                 </a:solidFill>
                 <a:latin typeface="Aptos"/>
               </a:rPr>
-              <a:t>Atlas kattaa maailman tutkimusrunkona, ei vielä markkina-arvona</a:t>
+              <a:t>Atlas: 195 maata (UN193+VA+PS); tutkimusrunko ei ole markkina-arvo</a:t>
             </a:r>
           </a:p>
         </p:txBody>
@@ -4900,7 +4900,7 @@
                 </a:solidFill>
                 <a:latin typeface="Aptos"/>
               </a:rPr>
-              <a:t>Julkinen riippumaton evidenssikooste · 2026.07.22-7 · 2026-07-22 · Lähteet: UN; Atlas</a:t>
+              <a:t>Julkinen riippumaton evidenssikooste · 2026.07.22-8 · 2026-07-22 · Lähteet: UN; Atlas</a:t>
             </a:r>
           </a:p>
         </p:txBody>
@@ -4949,7 +4949,7 @@
         <p:spPr>
           <a:xfrm>
             <a:off x="530352" y="1719072"/>
-            <a:ext cx="3532632" cy="1371600"/>
+            <a:ext cx="2585466" cy="1371600"/>
           </a:xfrm>
           <a:prstGeom prst="roundRect">
             <a:avLst>
@@ -4996,7 +4996,7 @@
         <p:spPr>
           <a:xfrm>
             <a:off x="694944" y="1883664"/>
-            <a:ext cx="3203448" cy="530352"/>
+            <a:ext cx="2256282" cy="530352"/>
           </a:xfrm>
           <a:prstGeom prst="rect">
             <a:avLst/>
@@ -5017,7 +5017,7 @@
                 </a:solidFill>
                 <a:latin typeface="Aptos"/>
               </a:rPr>
-              <a:t>195</a:t>
+              <a:t>5</a:t>
             </a:r>
           </a:p>
         </p:txBody>
@@ -5031,7 +5031,7 @@
         <p:spPr>
           <a:xfrm>
             <a:off x="694944" y="2468879"/>
-            <a:ext cx="3203448" cy="438912"/>
+            <a:ext cx="2256282" cy="438912"/>
           </a:xfrm>
           <a:prstGeom prst="rect">
             <a:avLst/>
@@ -5052,7 +5052,7 @@
                 </a:solidFill>
                 <a:latin typeface="Aptos"/>
               </a:rPr>
-              <a:t>maata universumissa</a:t>
+              <a:t>A-luokan maata</a:t>
             </a:r>
           </a:p>
         </p:txBody>
@@ -5065,8 +5065,8 @@
         </p:nvSpPr>
         <p:spPr>
           <a:xfrm>
-            <a:off x="4319016" y="1719072"/>
-            <a:ext cx="3532632" cy="1371600"/>
+            <a:off x="3371850" y="1719072"/>
+            <a:ext cx="2585466" cy="1371600"/>
           </a:xfrm>
           <a:prstGeom prst="roundRect">
             <a:avLst>
@@ -5112,8 +5112,8 @@
         </p:nvSpPr>
         <p:spPr>
           <a:xfrm>
-            <a:off x="4483608" y="1883664"/>
-            <a:ext cx="3203448" cy="530352"/>
+            <a:off x="3536442" y="1883664"/>
+            <a:ext cx="2256282" cy="530352"/>
           </a:xfrm>
           <a:prstGeom prst="rect">
             <a:avLst/>
@@ -5134,7 +5134,7 @@
                 </a:solidFill>
                 <a:latin typeface="Aptos"/>
               </a:rPr>
-              <a:t>37</a:t>
+              <a:t>13</a:t>
             </a:r>
           </a:p>
         </p:txBody>
@@ -5147,8 +5147,8 @@
         </p:nvSpPr>
         <p:spPr>
           <a:xfrm>
-            <a:off x="4483608" y="2468879"/>
-            <a:ext cx="3203448" cy="438912"/>
+            <a:off x="3536442" y="2468879"/>
+            <a:ext cx="2256282" cy="438912"/>
           </a:xfrm>
           <a:prstGeom prst="rect">
             <a:avLst/>
@@ -5169,7 +5169,7 @@
                 </a:solidFill>
                 <a:latin typeface="Aptos"/>
               </a:rPr>
-              <a:t>evidenssimerkintää</a:t>
+              <a:t>B-luokan maata</a:t>
             </a:r>
           </a:p>
         </p:txBody>
@@ -5182,8 +5182,8 @@
         </p:nvSpPr>
         <p:spPr>
           <a:xfrm>
-            <a:off x="8107680" y="1719072"/>
-            <a:ext cx="3532632" cy="1371600"/>
+            <a:off x="6213348" y="1719072"/>
+            <a:ext cx="2585466" cy="1371600"/>
           </a:xfrm>
           <a:prstGeom prst="roundRect">
             <a:avLst>
@@ -5229,8 +5229,8 @@
         </p:nvSpPr>
         <p:spPr>
           <a:xfrm>
-            <a:off x="8272272" y="1883664"/>
-            <a:ext cx="3203448" cy="530352"/>
+            <a:off x="6377940" y="1883664"/>
+            <a:ext cx="2256282" cy="530352"/>
           </a:xfrm>
           <a:prstGeom prst="rect">
             <a:avLst/>
@@ -5251,6 +5251,123 @@
                 </a:solidFill>
                 <a:latin typeface="Aptos"/>
               </a:rPr>
+              <a:t>19</a:t>
+            </a:r>
+          </a:p>
+        </p:txBody>
+      </p:sp>
+      <p:sp>
+        <p:nvSpPr>
+          <p:cNvPr id="16" name="TextBox 15"/>
+          <p:cNvSpPr txBox="1"/>
+          <p:nvPr/>
+        </p:nvSpPr>
+        <p:spPr>
+          <a:xfrm>
+            <a:off x="6377940" y="2468879"/>
+            <a:ext cx="2256282" cy="438912"/>
+          </a:xfrm>
+          <a:prstGeom prst="rect">
+            <a:avLst/>
+          </a:prstGeom>
+          <a:noFill/>
+        </p:spPr>
+        <p:txBody>
+          <a:bodyPr wrap="square" lIns="36576" rIns="36576" tIns="36576" bIns="36576" anchor="t">
+            <a:spAutoFit/>
+          </a:bodyPr>
+          <a:lstStyle/>
+          <a:p>
+            <a:pPr algn="l"/>
+            <a:r>
+              <a:rPr sz="1400" b="0">
+                <a:solidFill>
+                  <a:srgbClr val="5B6B75"/>
+                </a:solidFill>
+                <a:latin typeface="Aptos"/>
+              </a:rPr>
+              <a:t>C-luokan maata</a:t>
+            </a:r>
+          </a:p>
+        </p:txBody>
+      </p:sp>
+      <p:sp>
+        <p:nvSpPr>
+          <p:cNvPr id="17" name="Rounded Rectangle 16"/>
+          <p:cNvSpPr/>
+          <p:nvPr/>
+        </p:nvSpPr>
+        <p:spPr>
+          <a:xfrm>
+            <a:off x="9054846" y="1719072"/>
+            <a:ext cx="2585466" cy="1371600"/>
+          </a:xfrm>
+          <a:prstGeom prst="roundRect">
+            <a:avLst>
+              <a:gd name="adj" fmla="val 8000"/>
+            </a:avLst>
+          </a:prstGeom>
+          <a:solidFill>
+            <a:srgbClr val="F6F9FA"/>
+          </a:solidFill>
+          <a:ln>
+            <a:solidFill>
+              <a:srgbClr val="CBD8DE"/>
+            </a:solidFill>
+          </a:ln>
+        </p:spPr>
+        <p:style>
+          <a:lnRef idx="1">
+            <a:schemeClr val="accent1"/>
+          </a:lnRef>
+          <a:fillRef idx="3">
+            <a:schemeClr val="accent1"/>
+          </a:fillRef>
+          <a:effectRef idx="2">
+            <a:schemeClr val="accent1"/>
+          </a:effectRef>
+          <a:fontRef idx="minor">
+            <a:schemeClr val="lt1"/>
+          </a:fontRef>
+        </p:style>
+        <p:txBody>
+          <a:bodyPr rtlCol="0" anchor="ctr"/>
+          <a:lstStyle/>
+          <a:p>
+            <a:pPr algn="ctr"/>
+          </a:p>
+        </p:txBody>
+      </p:sp>
+      <p:sp>
+        <p:nvSpPr>
+          <p:cNvPr id="18" name="TextBox 17"/>
+          <p:cNvSpPr txBox="1"/>
+          <p:nvPr/>
+        </p:nvSpPr>
+        <p:spPr>
+          <a:xfrm>
+            <a:off x="9219438" y="1883664"/>
+            <a:ext cx="2256282" cy="530352"/>
+          </a:xfrm>
+          <a:prstGeom prst="rect">
+            <a:avLst/>
+          </a:prstGeom>
+          <a:noFill/>
+        </p:spPr>
+        <p:txBody>
+          <a:bodyPr wrap="square" lIns="36576" rIns="36576" tIns="36576" bIns="36576" anchor="t">
+            <a:spAutoFit/>
+          </a:bodyPr>
+          <a:lstStyle/>
+          <a:p>
+            <a:pPr algn="l"/>
+            <a:r>
+              <a:rPr sz="2700" b="1">
+                <a:solidFill>
+                  <a:srgbClr val="138A72"/>
+                </a:solidFill>
+                <a:latin typeface="Aptos"/>
+              </a:rPr>
               <a:t>158</a:t>
             </a:r>
           </a:p>
@@ -5258,14 +5375,14 @@
       </p:sp>
       <p:sp>
         <p:nvSpPr>
-          <p:cNvPr id="16" name="TextBox 15"/>
-          <p:cNvSpPr txBox="1"/>
-          <p:nvPr/>
-        </p:nvSpPr>
-        <p:spPr>
-          <a:xfrm>
-            <a:off x="8272272" y="2468879"/>
-            <a:ext cx="3203448" cy="438912"/>
+          <p:cNvPr id="19" name="TextBox 18"/>
+          <p:cNvSpPr txBox="1"/>
+          <p:nvPr/>
+        </p:nvSpPr>
+        <p:spPr>
+          <a:xfrm>
+            <a:off x="9219438" y="2468879"/>
+            <a:ext cx="2256282" cy="438912"/>
           </a:xfrm>
           <a:prstGeom prst="rect">
             <a:avLst/>
@@ -5293,7 +5410,7 @@
       </p:sp>
       <p:sp>
         <p:nvSpPr>
-          <p:cNvPr id="17" name="TextBox 16"/>
+          <p:cNvPr id="20" name="TextBox 19"/>
           <p:cNvSpPr txBox="1"/>
           <p:nvPr/>
         </p:nvSpPr>
@@ -5321,14 +5438,14 @@
                 </a:solidFill>
                 <a:latin typeface="Aptos"/>
               </a:rPr>
-              <a:t>Kattavuus tarkoittaa tutkimusrivejä; useimmista maista puuttuu virallinen vuosimyynti.</a:t>
-            </a:r>
-          </a:p>
-        </p:txBody>
-      </p:sp>
-      <p:sp>
-        <p:nvSpPr>
-          <p:cNvPr id="18" name="Rounded Rectangle 17"/>
+              <a:t>37 evidenssimerkintää; universumin YK-osuus on 193 jäsenvaltiota.</a:t>
+            </a:r>
+          </a:p>
+        </p:txBody>
+      </p:sp>
+      <p:sp>
+        <p:nvSpPr>
+          <p:cNvPr id="21" name="Rounded Rectangle 20"/>
           <p:cNvSpPr/>
           <p:nvPr/>
         </p:nvSpPr>
@@ -5375,7 +5492,7 @@
       </p:sp>
       <p:sp>
         <p:nvSpPr>
-          <p:cNvPr id="19" name="TextBox 18"/>
+          <p:cNvPr id="22" name="TextBox 21"/>
           <p:cNvSpPr txBox="1"/>
           <p:nvPr/>
         </p:nvSpPr>
@@ -5410,7 +5527,7 @@
       </p:sp>
       <p:sp>
         <p:nvSpPr>
-          <p:cNvPr id="20" name="TextBox 19"/>
+          <p:cNvPr id="23" name="TextBox 22"/>
           <p:cNvSpPr txBox="1"/>
           <p:nvPr/>
         </p:nvSpPr>
@@ -5526,7 +5643,7 @@
                 </a:solidFill>
                 <a:latin typeface="Aptos"/>
               </a:rPr>
-              <a:t>Viiden maan viralliset havainnot mittaavat eri asioita</a:t>
+              <a:t>Viralliset havainnot 5 maasta mittaavat eri asioita</a:t>
             </a:r>
           </a:p>
         </p:txBody>
@@ -5651,7 +5768,7 @@
                 </a:solidFill>
                 <a:latin typeface="Aptos"/>
               </a:rPr>
-              <a:t>Julkinen riippumaton evidenssikooste · 2026.07.22-7 · 2026-07-22 · Lähteet: Health Canada; Destatis; Vero; Sejm; Ruotsin hallitus</a:t>
+              <a:t>Julkinen riippumaton evidenssikooste · 2026.07.22-8 · 2026-07-22 · Lähteet: Health Canada; Destatis; Vero; Sejm; Ruotsin hallitus</a:t>
             </a:r>
           </a:p>
         </p:txBody>
@@ -5851,7 +5968,7 @@
                         </a:defRPr>
                       </a:pPr>
                       <a:r>
-                        <a:t>1.16 mrd CAD toimitusarvo; 1.252 milj. l nestettä</a:t>
+                        <a:t>1,16 mrd CAD toimitusarvo; 1 251 843 l nestettä</a:t>
                       </a:r>
                     </a:p>
                   </a:txBody>
@@ -5925,7 +6042,7 @@
                         </a:defRPr>
                       </a:pPr>
                       <a:r>
-                        <a:t>1.241 milj. l → 1.518 milj. l verotettua nestettä</a:t>
+                        <a:t>1,241 milj. l → 1,518 milj. l verotettua nestettä</a:t>
                       </a:r>
                     </a:p>
                   </a:txBody>
@@ -5999,7 +6116,7 @@
                         </a:defRPr>
                       </a:pPr>
                       <a:r>
-                        <a:t>11 801,062 l; 3,540 milj. € valmisteveroa</a:t>
+                        <a:t>11 801,062 l; 3,54 milj. EUR valmisteveroa</a:t>
                       </a:r>
                     </a:p>
                   </a:txBody>
@@ -6073,7 +6190,7 @@
                         </a:defRPr>
                       </a:pPr>
                       <a:r>
-                        <a:t>805 441 l; 993,1 milj. PLN e-nesteveroa</a:t>
+                        <a:t>805 441 l; 993,1 milj. PLN valmisteveroa</a:t>
                       </a:r>
                     </a:p>
                   </a:txBody>
@@ -6405,7 +6522,7 @@
                 </a:solidFill>
                 <a:latin typeface="Aptos"/>
               </a:rPr>
-              <a:t>Julkinen riippumaton evidenssikooste · 2026.07.22-7 · 2026-07-22 · Lähteet: Health Canada 2024</a:t>
+              <a:t>Julkinen riippumaton evidenssikooste · 2026.07.22-8 · 2026-07-22 · Lähteet: Health Canada 2024</a:t>
             </a:r>
           </a:p>
         </p:txBody>
@@ -6522,7 +6639,7 @@
                 </a:solidFill>
                 <a:latin typeface="Aptos"/>
               </a:rPr>
-              <a:t>1.16 mrd CAD</a:t>
+              <a:t>1,16 mrd CAD</a:t>
             </a:r>
           </a:p>
         </p:txBody>
@@ -6639,7 +6756,7 @@
                 </a:solidFill>
                 <a:latin typeface="Aptos"/>
               </a:rPr>
-              <a:t>118,9 milj.</a:t>
+              <a:t>118,9 milj. yks.</a:t>
             </a:r>
           </a:p>
         </p:txBody>
@@ -6674,7 +6791,7 @@
                 </a:solidFill>
                 <a:latin typeface="Aptos"/>
               </a:rPr>
-              <a:t>raportoitua yksikköä</a:t>
+              <a:t>raportoitua yksikkömäärää</a:t>
             </a:r>
           </a:p>
         </p:txBody>
@@ -6756,7 +6873,7 @@
                 </a:solidFill>
                 <a:latin typeface="Aptos"/>
               </a:rPr>
-              <a:t>1.252 milj. l</a:t>
+              <a:t>1,252 milj. l</a:t>
             </a:r>
           </a:p>
         </p:txBody>
@@ -6826,7 +6943,7 @@
                 </a:solidFill>
                 <a:latin typeface="Aptos"/>
               </a:rPr>
-              <a:t>Virallinen koko vuoden havainto kattaa neljä vaping-tuoteryhmää.</a:t>
+              <a:t>Virallinen koko vuoden toimitusarvo tukku- tai vähittäismyyjille kaikissa neljässä raportoidussa tuoteryhmässä.</a:t>
             </a:r>
           </a:p>
         </p:txBody>
@@ -6943,7 +7060,7 @@
                 </a:solidFill>
                 <a:latin typeface="Aptos"/>
               </a:rPr>
-              <a:t>Tukku-/vähittäismyyjille toimitettu arvo ei ole kuluttajien kassamyynti; varasto, kate ja kanava on täsmäytettävä.</a:t>
+              <a:t>Virallinen koko vuoden toimitusarvo tukku- tai vähittäismyyjille kaikissa neljässä raportoidussa tuoteryhmässä. Kyse ei ole kuluttajien vähittäisostoista, ja Health Canada voi tarkistaa tietoa.</a:t>
             </a:r>
           </a:p>
         </p:txBody>
@@ -7156,7 +7273,7 @@
                 </a:solidFill>
                 <a:latin typeface="Aptos"/>
               </a:rPr>
-              <a:t>Julkinen riippumaton evidenssikooste · 2026.07.22-7 · 2026-07-22 · Lähteet: Destatis 73411-0003</a:t>
+              <a:t>Julkinen riippumaton evidenssikooste · 2026.07.22-8 · 2026-07-22 · Lähteet: Destatis</a:t>
             </a:r>
           </a:p>
         </p:txBody>
@@ -7357,7 +7474,7 @@
                         </a:defRPr>
                       </a:pPr>
                       <a:r>
-                        <a:t>1.241 milj. l</a:t>
+                        <a:t>1,241 milj. l</a:t>
                       </a:r>
                     </a:p>
                   </a:txBody>
@@ -7381,7 +7498,7 @@
                         </a:defRPr>
                       </a:pPr>
                       <a:r>
-                        <a:t>201 milj. €</a:t>
+                        <a:t>201 milj. EUR</a:t>
                       </a:r>
                     </a:p>
                   </a:txBody>
@@ -7455,7 +7572,7 @@
                         </a:defRPr>
                       </a:pPr>
                       <a:r>
-                        <a:t>1.284 milj. l</a:t>
+                        <a:t>1,284 milj. l</a:t>
                       </a:r>
                     </a:p>
                   </a:txBody>
@@ -7479,7 +7596,7 @@
                         </a:defRPr>
                       </a:pPr>
                       <a:r>
-                        <a:t>266 milj. €</a:t>
+                        <a:t>266 milj. EUR</a:t>
                       </a:r>
                     </a:p>
                   </a:txBody>
@@ -7553,7 +7670,7 @@
                         </a:defRPr>
                       </a:pPr>
                       <a:r>
-                        <a:t>1.518 milj. l</a:t>
+                        <a:t>1,518 milj. l</a:t>
                       </a:r>
                     </a:p>
                   </a:txBody>
@@ -7577,7 +7694,7 @@
                         </a:defRPr>
                       </a:pPr>
                       <a:r>
-                        <a:t>404 milj. €</a:t>
+                        <a:t>404 milj. EUR</a:t>
                       </a:r>
                     </a:p>
                   </a:txBody>
@@ -7859,7 +7976,7 @@
                 </a:solidFill>
                 <a:latin typeface="Aptos"/>
               </a:rPr>
-              <a:t>Julkinen riippumaton evidenssikooste · 2026.07.22-7 · 2026-07-22 · Lähteet: Destatis; inTaste-hintapisteet</a:t>
+              <a:t>Julkinen riippumaton evidenssikooste · 2026.07.22-8 · 2026-07-22 · Lähteet: Destatis; inTaste.de</a:t>
             </a:r>
           </a:p>
         </p:txBody>
@@ -7976,7 +8093,7 @@
                 </a:solidFill>
                 <a:latin typeface="Aptos"/>
               </a:rPr>
-              <a:t>667.9 M€</a:t>
+              <a:t>667,92 milj. EUR</a:t>
             </a:r>
           </a:p>
         </p:txBody>
@@ -8011,7 +8128,7 @@
                 </a:solidFill>
                 <a:latin typeface="Aptos"/>
               </a:rPr>
-              <a:t>0,44 €/ml</a:t>
+              <a:t>0,44 EUR/ml</a:t>
             </a:r>
           </a:p>
         </p:txBody>
@@ -8093,7 +8210,7 @@
                 </a:solidFill>
                 <a:latin typeface="Aptos"/>
               </a:rPr>
-              <a:t>1 199.2 M€</a:t>
+              <a:t>1 199,22 milj. EUR</a:t>
             </a:r>
           </a:p>
         </p:txBody>
@@ -8128,7 +8245,7 @@
                 </a:solidFill>
                 <a:latin typeface="Aptos"/>
               </a:rPr>
-              <a:t>0,79 €/ml</a:t>
+              <a:t>0,79 EUR/ml</a:t>
             </a:r>
           </a:p>
         </p:txBody>
@@ -8210,7 +8327,7 @@
                 </a:solidFill>
                 <a:latin typeface="Aptos"/>
               </a:rPr>
-              <a:t>1 654.6 M€</a:t>
+              <a:t>1 654,62 milj. EUR</a:t>
             </a:r>
           </a:p>
         </p:txBody>
@@ -8245,7 +8362,7 @@
                 </a:solidFill>
                 <a:latin typeface="Aptos"/>
               </a:rPr>
-              <a:t>1,09 €/ml</a:t>
+              <a:t>1,09 EUR/ml</a:t>
             </a:r>
           </a:p>
         </p:txBody>
@@ -8397,7 +8514,7 @@
                 </a:solidFill>
                 <a:latin typeface="Aptos"/>
               </a:rPr>
-              <a:t>Vuoden 2025 alustava määrä kerrotaan kolmella yhden verkkokaupan vuoden 2026 hinnalla. Confidence = low; laitteet ja useita kanava-/mix-tekijöitä puuttuu.</a:t>
+              <a:t>Ei havaittua myyntiä. Laskelma kertoo vuoden 2025 alustavan verotetun nestemäärän kolmella yksittäisellä saksalaisen verkkokaupan vuoden 2026 hinnalla. Vuosiero, yhden kaupan hintakori, tuotejakauma ja pois rajatut tuoteryhmät tekevät luottamustasosta matalan.</a:t>
             </a:r>
           </a:p>
         </p:txBody>
@@ -8610,7 +8727,7 @@
                 </a:solidFill>
                 <a:latin typeface="Aptos"/>
               </a:rPr>
-              <a:t>Julkinen riippumaton evidenssikooste · 2026.07.22-7 · 2026-07-22 · Lähteet: IMARC; Grand View Research; Fortune Business Insights</a:t>
+              <a:t>Julkinen riippumaton evidenssikooste · 2026.07.22-8 · 2026-07-22 · Lähteet: IMARC; GVR; Fortune</a:t>
             </a:r>
           </a:p>
         </p:txBody>
@@ -8727,7 +8844,7 @@
                 </a:solidFill>
                 <a:latin typeface="Aptos"/>
               </a:rPr>
-              <a:t>$26,0 mrd</a:t>
+              <a:t>26,0 mrd USD</a:t>
             </a:r>
           </a:p>
         </p:txBody>
@@ -8844,7 +8961,7 @@
                 </a:solidFill>
                 <a:latin typeface="Aptos"/>
               </a:rPr>
-              <a:t>$45,7 mrd</a:t>
+              <a:t>45,7 mrd USD</a:t>
             </a:r>
           </a:p>
         </p:txBody>
@@ -8961,7 +9078,7 @@
                 </a:solidFill>
                 <a:latin typeface="Aptos"/>
               </a:rPr>
-              <a:t>$46,32 mrd</a:t>
+              <a:t>46,32 mrd USD</a:t>
             </a:r>
           </a:p>
         </p:txBody>
@@ -9236,7 +9353,7 @@
                 </a:solidFill>
                 <a:latin typeface="Aptos"/>
               </a:rPr>
-              <a:t>Hyväksyttävä maailmanestimaatti tarvitsee vähintään kolme yhteensopivaa luovuttajaa</a:t>
+              <a:t>Hyväksyttävä maailmanestimaatti tarvitsee vähintään 3 yhteensopivaa luovuttajaa</a:t>
             </a:r>
           </a:p>
         </p:txBody>
@@ -9361,7 +9478,7 @@
                 </a:solidFill>
                 <a:latin typeface="Aptos"/>
               </a:rPr>
-              <a:t>Julkinen riippumaton evidenssikooste · 2026.07.22-7 · 2026-07-22 · Lähteet: Market-values modelReadiness</a:t>
+              <a:t>Julkinen riippumaton evidenssikooste · 2026.07.22-8 · 2026-07-22 · Lähteet: Market-values modelReadiness</a:t>
             </a:r>
           </a:p>
         </p:txBody>
@@ -9841,7 +9958,7 @@
                 </a:solidFill>
                 <a:latin typeface="Aptos"/>
               </a:rPr>
-              <a:t>Julkinen riippumaton evidenssikooste · 2026.07.22-7 · 2026-07-22 · Lähteet: WIPO valuation; Evidence Register</a:t>
+              <a:t>Julkinen riippumaton evidenssikooste · 2026.07.22-8 · 2026-07-22 · Lähteet: WIPO valuation; Evidence Register</a:t>
             </a:r>
           </a:p>
         </p:txBody>
@@ -10189,7 +10306,7 @@
                         </a:defRPr>
                       </a:pPr>
                       <a:r>
-                        <a:t>Rajattu Saksan näyttö</a:t>
+                        <a:t>Rajattu näyttö: Saksa</a:t>
                       </a:r>
                     </a:p>
                   </a:txBody>
@@ -10595,7 +10712,7 @@
                 </a:solidFill>
                 <a:latin typeface="Aptos"/>
               </a:rPr>
-              <a:t>Julkinen riippumaton evidenssikooste · 2026.07.22-7 · 2026-07-22 · Lähteet: EPO; Saksan tuomiot; WIPO</a:t>
+              <a:t>Julkinen riippumaton evidenssikooste · 2026.07.22-8 · 2026-07-22 · Lähteet: EPO; Saksa — viralliset tuomiot; WIPO</a:t>
             </a:r>
           </a:p>
         </p:txBody>
@@ -10707,7 +10824,7 @@
               </a:defRPr>
             </a:pPr>
             <a:r>
-              <a:t>•  EPO:n muutettu B2-patentti ja Saksan ratkaisut muodostavat harvinaisen vahvan oikeusnäytön ankkurin.</a:t>
+              <a:t>•  EPO:n muutettu EP3032975B2 ja Saksan kaksi virallista ratkaisua muodostavat oikeusnäytön ankkurin.</a:t>
             </a:r>
           </a:p>
           <a:p>
@@ -10726,7 +10843,7 @@
               </a:defRPr>
             </a:pPr>
             <a:r>
-              <a:t>•  Markkina-aineisto kattaa 195 maan tutkimusrungon, mutta yhteismitallista vähittäisarvoa ei vielä ole.</a:t>
+              <a:t>•  Markkina-aineisto kattaa 195 maan tutkimusrungon, mutta yhteismitallisia retail-luovuttajia on 0.</a:t>
             </a:r>
           </a:p>
           <a:p>
@@ -11075,7 +11192,7 @@
                 </a:solidFill>
                 <a:latin typeface="Aptos"/>
               </a:rPr>
-              <a:t>Julkinen riippumaton evidenssikooste · 2026.07.22-7 · 2026-07-22 · Lähteet: WIPO licensing; IP Finance</a:t>
+              <a:t>Julkinen riippumaton evidenssikooste · 2026.07.22-8 · 2026-07-22 · Lähteet: WIPO licensing; IP Finance</a:t>
             </a:r>
           </a:p>
         </p:txBody>
@@ -11555,7 +11672,7 @@
                 </a:solidFill>
                 <a:latin typeface="Aptos"/>
               </a:rPr>
-              <a:t>Julkinen riippumaton evidenssikooste · 2026.07.22-7 · 2026-07-22 · Lähteet: Evidence Register; EPO</a:t>
+              <a:t>Julkinen riippumaton evidenssikooste · 2026.07.22-8 · 2026-07-22 · Lähteet: Evidence Register; EPO</a:t>
             </a:r>
           </a:p>
         </p:txBody>
@@ -12235,7 +12352,7 @@
                 </a:solidFill>
                 <a:latin typeface="Aptos"/>
               </a:rPr>
-              <a:t>Julkinen riippumaton evidenssikooste · 2026.07.22-7 · 2026-07-22 · Lähteet: EP3032975B2; Saksan tuomio</a:t>
+              <a:t>Julkinen riippumaton evidenssikooste · 2026.07.22-8 · 2026-07-22 · Lähteet: EP3032975B2; 7 O 3341/24</a:t>
             </a:r>
           </a:p>
         </p:txBody>
@@ -13126,7 +13243,7 @@
                 </a:solidFill>
                 <a:latin typeface="Aptos"/>
               </a:rPr>
-              <a:t>Julkinen riippumaton evidenssikooste · 2026.07.22-7 · 2026-07-22 · Lähteet: WIPO dispute resolution; EPO IPscore</a:t>
+              <a:t>Julkinen riippumaton evidenssikooste · 2026.07.22-8 · 2026-07-22 · Lähteet: WIPO dispute resolution; EPO IPscore</a:t>
             </a:r>
           </a:p>
         </p:txBody>
@@ -14017,7 +14134,7 @@
                 </a:solidFill>
                 <a:latin typeface="Aptos"/>
               </a:rPr>
-              <a:t>Julkinen riippumaton evidenssikooste · 2026.07.22-7 · 2026-07-22 · Lähteet: WIPO licensing; IP Finance; TPLF mapping</a:t>
+              <a:t>Julkinen riippumaton evidenssikooste · 2026.07.22-8 · 2026-07-22 · Lähteet: WIPO licensing; IP Finance; TPLF mapping</a:t>
             </a:r>
           </a:p>
         </p:txBody>
@@ -14771,7 +14888,7 @@
                 </a:solidFill>
                 <a:latin typeface="Aptos"/>
               </a:rPr>
-              <a:t>Julkinen riippumaton evidenssikooste · 2026.07.22-7 · 2026-07-22 · Lähteet: Evidence Register; WIPO valuation</a:t>
+              <a:t>Julkinen riippumaton evidenssikooste · 2026.07.22-8 · 2026-07-22 · Lähteet: Evidence Register; WIPO valuation</a:t>
             </a:r>
           </a:p>
         </p:txBody>
@@ -15599,7 +15716,7 @@
                 </a:solidFill>
                 <a:latin typeface="Aptos"/>
               </a:rPr>
-              <a:t>Julkinen riippumaton evidenssikooste · 2026.07.22-7 · 2026-07-22 · Lähteet: WIPO valuation</a:t>
+              <a:t>Julkinen riippumaton evidenssikooste · 2026.07.22-8 · 2026-07-22 · Lähteet: WIPO valuation</a:t>
             </a:r>
           </a:p>
         </p:txBody>
@@ -16498,7 +16615,7 @@
                 </a:solidFill>
                 <a:latin typeface="Aptos"/>
               </a:rPr>
-              <a:t>Julkinen riippumaton evidenssikooste · 2026.07.22-7 · 2026-07-22 · Lähteet: Evidence Register</a:t>
+              <a:t>Julkinen riippumaton evidenssikooste · 2026.07.22-8 · 2026-07-22 · Lähteet: Evidence Register</a:t>
             </a:r>
           </a:p>
         </p:txBody>
@@ -17252,7 +17369,7 @@
                 </a:solidFill>
                 <a:latin typeface="Aptos"/>
               </a:rPr>
-              <a:t>Julkinen riippumaton evidenssikooste · 2026.07.22-7 · 2026-07-22 · Lähteet: Evidence Register</a:t>
+              <a:t>Julkinen riippumaton evidenssikooste · 2026.07.22-8 · 2026-07-22 · Lähteet: Evidence Register</a:t>
             </a:r>
           </a:p>
         </p:txBody>
@@ -18080,7 +18197,7 @@
                 </a:solidFill>
                 <a:latin typeface="Aptos"/>
               </a:rPr>
-              <a:t>Julkinen riippumaton evidenssikooste · 2026.07.22-7 · 2026-07-22 · Lähteet: Evidence Register; changelog</a:t>
+              <a:t>Julkinen riippumaton evidenssikooste · 2026.07.22-8 · 2026-07-22 · Lähteet: Evidence Register; changelog</a:t>
             </a:r>
           </a:p>
         </p:txBody>
@@ -18971,7 +19088,7 @@
                 </a:solidFill>
                 <a:latin typeface="Aptos"/>
               </a:rPr>
-              <a:t>Julkinen riippumaton evidenssikooste · 2026.07.22-7 · 2026-07-22 · Lähteet: EPO; DE 8 Ni 18/24; DE 7 O 3341/24</a:t>
+              <a:t>Julkinen riippumaton evidenssikooste · 2026.07.22-8 · 2026-07-22 · Lähteet: EPO; 8 Ni 18/24 (EP); 7 O 3341/24</a:t>
             </a:r>
           </a:p>
         </p:txBody>
@@ -19123,7 +19240,7 @@
                         </a:defRPr>
                       </a:pPr>
                       <a:r>
-                        <a:t>EPO pysytti patentin muutettuna</a:t>
+                        <a:t>EPO:n keskitetty riitautus päättyi patentin pysyttämiseen muutettuna</a:t>
                       </a:r>
                     </a:p>
                   </a:txBody>
@@ -19197,7 +19314,7 @@
                         </a:defRPr>
                       </a:pPr>
                       <a:r>
-                        <a:t>Saksan mitätöintiratkaisu</a:t>
+                        <a:t>Mitätöintikanne hylättiin; valitus vireillä</a:t>
                       </a:r>
                     </a:p>
                   </a:txBody>
@@ -19271,7 +19388,7 @@
                         </a:defRPr>
                       </a:pPr>
                       <a:r>
-                        <a:t>Saksan loukkausratkaisu</a:t>
+                        <a:t>Tarkasteltujen tuotteiden todettiin loukkaavan patenttia</a:t>
                       </a:r>
                     </a:p>
                   </a:txBody>
@@ -19502,7 +19619,7 @@
               </a:defRPr>
             </a:pPr>
             <a:r>
-              <a:t>•  Vahva lähtökohta: dokumentoitu patenttiydin ja virallista Saksan oikeusnäyttöä.</a:t>
+              <a:t>•  Vahva lähtökohta: dokumentoitu patenttiydin ja Saksan virallista oikeusnäyttöä.</a:t>
             </a:r>
           </a:p>
           <a:p>
@@ -19594,7 +19711,7 @@
                 </a:solidFill>
                 <a:latin typeface="Aptos"/>
               </a:rPr>
-              <a:t>Versio 2026.07.22-7 · 2026-07-22 · 30 / 30</a:t>
+              <a:t>Versio 2026.07.22-8 · 2026-07-22 · 30 / 30</a:t>
             </a:r>
           </a:p>
         </p:txBody>
@@ -19807,7 +19924,7 @@
                 </a:solidFill>
                 <a:latin typeface="Aptos"/>
               </a:rPr>
-              <a:t>Julkinen riippumaton evidenssikooste · 2026.07.22-7 · 2026-07-22 · Lähteet: Evidence Register; WIPO</a:t>
+              <a:t>Julkinen riippumaton evidenssikooste · 2026.07.22-8 · 2026-07-22 · Lähteet: Evidence Register; WIPO</a:t>
             </a:r>
           </a:p>
         </p:txBody>
@@ -19938,7 +20055,7 @@
               </a:defRPr>
             </a:pPr>
             <a:r>
-              <a:t>•  Tuote- ja myyntikytkentä on vahvistettu vain rajatusti Saksan tuomiossa.</a:t>
+              <a:t>•  Tuote- ja myyntikytkentä on vahvistettu vain rajatusti: Saksa, 7 O 3341/24.</a:t>
             </a:r>
           </a:p>
           <a:p>
@@ -20287,7 +20404,7 @@
                 </a:solidFill>
                 <a:latin typeface="Aptos"/>
               </a:rPr>
-              <a:t>Julkinen riippumaton evidenssikooste · 2026.07.22-7 · 2026-07-22 · Lähteet: EP3032975B2</a:t>
+              <a:t>Julkinen riippumaton evidenssikooste · 2026.07.22-8 · 2026-07-22 · Lähteet: EP3032975B2</a:t>
             </a:r>
           </a:p>
         </p:txBody>
@@ -20767,7 +20884,7 @@
                 </a:solidFill>
                 <a:latin typeface="Aptos"/>
               </a:rPr>
-              <a:t>Julkinen riippumaton evidenssikooste · 2026.07.22-7 · 2026-07-22 · Lähteet: EP3032975B2</a:t>
+              <a:t>Julkinen riippumaton evidenssikooste · 2026.07.22-8 · 2026-07-22 · Lähteet: EP3032975B2</a:t>
             </a:r>
           </a:p>
         </p:txBody>
@@ -21521,7 +21638,7 @@
                 </a:solidFill>
                 <a:latin typeface="Aptos"/>
               </a:rPr>
-              <a:t>Julkinen riippumaton evidenssikooste · 2026.07.22-7 · 2026-07-22 · Lähteet: EPO Register; B2</a:t>
+              <a:t>Julkinen riippumaton evidenssikooste · 2026.07.22-8 · 2026-07-22 · Lähteet: EPO Register; B2</a:t>
             </a:r>
           </a:p>
         </p:txBody>
@@ -21942,7 +22059,7 @@
                 </a:solidFill>
                 <a:latin typeface="Aptos"/>
               </a:rPr>
-              <a:t>EPO:n keskitetty väite- ja valitusmenettely on päättynyt.</a:t>
+              <a:t>EPO:n keskitetty väite- ja valitusmenettely päättynyt; kansallinen myöntämisen jälkeinen tila on erillinen.</a:t>
             </a:r>
           </a:p>
         </p:txBody>
@@ -22272,7 +22389,7 @@
                 </a:solidFill>
                 <a:latin typeface="Aptos"/>
               </a:rPr>
-              <a:t>Julkinen riippumaton evidenssikooste · 2026.07.22-7 · 2026-07-22 · Lähteet: EPO family; kansalliset rekisterit</a:t>
+              <a:t>Julkinen riippumaton evidenssikooste · 2026.07.22-8 · 2026-07-22 · Lähteet: EPO family; kansalliset rekisterit</a:t>
             </a:r>
           </a:p>
         </p:txBody>
@@ -22321,7 +22438,7 @@
         <p:spPr>
           <a:xfrm>
             <a:off x="530352" y="1719072"/>
-            <a:ext cx="3532632" cy="1371600"/>
+            <a:ext cx="2585466" cy="1371600"/>
           </a:xfrm>
           <a:prstGeom prst="roundRect">
             <a:avLst>
@@ -22368,7 +22485,7 @@
         <p:spPr>
           <a:xfrm>
             <a:off x="694944" y="1883664"/>
-            <a:ext cx="3203448" cy="530352"/>
+            <a:ext cx="2256282" cy="530352"/>
           </a:xfrm>
           <a:prstGeom prst="rect">
             <a:avLst/>
@@ -22403,7 +22520,7 @@
         <p:spPr>
           <a:xfrm>
             <a:off x="694944" y="2468879"/>
-            <a:ext cx="3203448" cy="438912"/>
+            <a:ext cx="2256282" cy="438912"/>
           </a:xfrm>
           <a:prstGeom prst="rect">
             <a:avLst/>
@@ -22437,8 +22554,8 @@
         </p:nvSpPr>
         <p:spPr>
           <a:xfrm>
-            <a:off x="4319016" y="1719072"/>
-            <a:ext cx="3532632" cy="1371600"/>
+            <a:off x="3371850" y="1719072"/>
+            <a:ext cx="2585466" cy="1371600"/>
           </a:xfrm>
           <a:prstGeom prst="roundRect">
             <a:avLst>
@@ -22484,8 +22601,8 @@
         </p:nvSpPr>
         <p:spPr>
           <a:xfrm>
-            <a:off x="4483608" y="1883664"/>
-            <a:ext cx="3203448" cy="530352"/>
+            <a:off x="3536442" y="1883664"/>
+            <a:ext cx="2256282" cy="530352"/>
           </a:xfrm>
           <a:prstGeom prst="rect">
             <a:avLst/>
@@ -22519,8 +22636,8 @@
         </p:nvSpPr>
         <p:spPr>
           <a:xfrm>
-            <a:off x="4483608" y="2468879"/>
-            <a:ext cx="3203448" cy="438912"/>
+            <a:off x="3536442" y="2468879"/>
+            <a:ext cx="2256282" cy="438912"/>
           </a:xfrm>
           <a:prstGeom prst="rect">
             <a:avLst/>
@@ -22541,7 +22658,7 @@
                 </a:solidFill>
                 <a:latin typeface="Aptos"/>
               </a:rPr>
-              <a:t>kansallista rekisteritarkistusta</a:t>
+              <a:t>tunnistettua menettelyä</a:t>
             </a:r>
           </a:p>
         </p:txBody>
@@ -22554,8 +22671,8 @@
         </p:nvSpPr>
         <p:spPr>
           <a:xfrm>
-            <a:off x="8107680" y="1719072"/>
-            <a:ext cx="3532632" cy="1371600"/>
+            <a:off x="6213348" y="1719072"/>
+            <a:ext cx="2585466" cy="1371600"/>
           </a:xfrm>
           <a:prstGeom prst="roundRect">
             <a:avLst>
@@ -22601,8 +22718,8 @@
         </p:nvSpPr>
         <p:spPr>
           <a:xfrm>
-            <a:off x="8272272" y="1883664"/>
-            <a:ext cx="3203448" cy="530352"/>
+            <a:off x="6377940" y="1883664"/>
+            <a:ext cx="2256282" cy="530352"/>
           </a:xfrm>
           <a:prstGeom prst="rect">
             <a:avLst/>
@@ -22623,6 +22740,123 @@
                 </a:solidFill>
                 <a:latin typeface="Aptos"/>
               </a:rPr>
+              <a:t>4</a:t>
+            </a:r>
+          </a:p>
+        </p:txBody>
+      </p:sp>
+      <p:sp>
+        <p:nvSpPr>
+          <p:cNvPr id="16" name="TextBox 15"/>
+          <p:cNvSpPr txBox="1"/>
+          <p:nvPr/>
+        </p:nvSpPr>
+        <p:spPr>
+          <a:xfrm>
+            <a:off x="6377940" y="2468879"/>
+            <a:ext cx="2256282" cy="438912"/>
+          </a:xfrm>
+          <a:prstGeom prst="rect">
+            <a:avLst/>
+          </a:prstGeom>
+          <a:noFill/>
+        </p:spPr>
+        <p:txBody>
+          <a:bodyPr wrap="square" lIns="36576" rIns="36576" tIns="36576" bIns="36576" anchor="t">
+            <a:spAutoFit/>
+          </a:bodyPr>
+          <a:lstStyle/>
+          <a:p>
+            <a:pPr algn="l"/>
+            <a:r>
+              <a:rPr sz="1400" b="0">
+                <a:solidFill>
+                  <a:srgbClr val="5B6B75"/>
+                </a:solidFill>
+                <a:latin typeface="Aptos"/>
+              </a:rPr>
+              <a:t>virallista kansallista rekisteritarkistusta</a:t>
+            </a:r>
+          </a:p>
+        </p:txBody>
+      </p:sp>
+      <p:sp>
+        <p:nvSpPr>
+          <p:cNvPr id="17" name="Rounded Rectangle 16"/>
+          <p:cNvSpPr/>
+          <p:nvPr/>
+        </p:nvSpPr>
+        <p:spPr>
+          <a:xfrm>
+            <a:off x="9054846" y="1719072"/>
+            <a:ext cx="2585466" cy="1371600"/>
+          </a:xfrm>
+          <a:prstGeom prst="roundRect">
+            <a:avLst>
+              <a:gd name="adj" fmla="val 8000"/>
+            </a:avLst>
+          </a:prstGeom>
+          <a:solidFill>
+            <a:srgbClr val="F6F9FA"/>
+          </a:solidFill>
+          <a:ln>
+            <a:solidFill>
+              <a:srgbClr val="CBD8DE"/>
+            </a:solidFill>
+          </a:ln>
+        </p:spPr>
+        <p:style>
+          <a:lnRef idx="1">
+            <a:schemeClr val="accent1"/>
+          </a:lnRef>
+          <a:fillRef idx="3">
+            <a:schemeClr val="accent1"/>
+          </a:fillRef>
+          <a:effectRef idx="2">
+            <a:schemeClr val="accent1"/>
+          </a:effectRef>
+          <a:fontRef idx="minor">
+            <a:schemeClr val="lt1"/>
+          </a:fontRef>
+        </p:style>
+        <p:txBody>
+          <a:bodyPr rtlCol="0" anchor="ctr"/>
+          <a:lstStyle/>
+          <a:p>
+            <a:pPr algn="ctr"/>
+          </a:p>
+        </p:txBody>
+      </p:sp>
+      <p:sp>
+        <p:nvSpPr>
+          <p:cNvPr id="18" name="TextBox 17"/>
+          <p:cNvSpPr txBox="1"/>
+          <p:nvPr/>
+        </p:nvSpPr>
+        <p:spPr>
+          <a:xfrm>
+            <a:off x="9219438" y="1883664"/>
+            <a:ext cx="2256282" cy="530352"/>
+          </a:xfrm>
+          <a:prstGeom prst="rect">
+            <a:avLst/>
+          </a:prstGeom>
+          <a:noFill/>
+        </p:spPr>
+        <p:txBody>
+          <a:bodyPr wrap="square" lIns="36576" rIns="36576" tIns="36576" bIns="36576" anchor="t">
+            <a:spAutoFit/>
+          </a:bodyPr>
+          <a:lstStyle/>
+          <a:p>
+            <a:pPr algn="l"/>
+            <a:r>
+              <a:rPr sz="2700" b="1">
+                <a:solidFill>
+                  <a:srgbClr val="138A72"/>
+                </a:solidFill>
+                <a:latin typeface="Aptos"/>
+              </a:rPr>
               <a:t>?</a:t>
             </a:r>
           </a:p>
@@ -22630,14 +22864,14 @@
       </p:sp>
       <p:sp>
         <p:nvSpPr>
-          <p:cNvPr id="16" name="TextBox 15"/>
-          <p:cNvSpPr txBox="1"/>
-          <p:nvPr/>
-        </p:nvSpPr>
-        <p:spPr>
-          <a:xfrm>
-            <a:off x="8272272" y="2468879"/>
-            <a:ext cx="3203448" cy="438912"/>
+          <p:cNvPr id="19" name="TextBox 18"/>
+          <p:cNvSpPr txBox="1"/>
+          <p:nvPr/>
+        </p:nvSpPr>
+        <p:spPr>
+          <a:xfrm>
+            <a:off x="9219438" y="2468879"/>
+            <a:ext cx="2256282" cy="438912"/>
           </a:xfrm>
           <a:prstGeom prst="rect">
             <a:avLst/>
@@ -22665,7 +22899,7 @@
       </p:sp>
       <p:sp>
         <p:nvSpPr>
-          <p:cNvPr id="17" name="TextBox 16"/>
+          <p:cNvPr id="20" name="TextBox 19"/>
           <p:cNvSpPr txBox="1"/>
           <p:nvPr/>
         </p:nvSpPr>
@@ -22700,7 +22934,7 @@
       </p:sp>
       <p:sp>
         <p:nvSpPr>
-          <p:cNvPr id="18" name="Rounded Rectangle 17"/>
+          <p:cNvPr id="21" name="Rounded Rectangle 20"/>
           <p:cNvSpPr/>
           <p:nvPr/>
         </p:nvSpPr>
@@ -22747,7 +22981,7 @@
       </p:sp>
       <p:sp>
         <p:nvSpPr>
-          <p:cNvPr id="19" name="TextBox 18"/>
+          <p:cNvPr id="22" name="TextBox 21"/>
           <p:cNvSpPr txBox="1"/>
           <p:nvPr/>
         </p:nvSpPr>
@@ -22782,7 +23016,7 @@
       </p:sp>
       <p:sp>
         <p:nvSpPr>
-          <p:cNvPr id="20" name="TextBox 19"/>
+          <p:cNvPr id="23" name="TextBox 22"/>
           <p:cNvSpPr txBox="1"/>
           <p:nvPr/>
         </p:nvSpPr>
@@ -23023,7 +23257,7 @@
                 </a:solidFill>
                 <a:latin typeface="Aptos"/>
               </a:rPr>
-              <a:t>Julkinen riippumaton evidenssikooste · 2026.07.22-7 · 2026-07-22 · Lähteet: Viralliset Saksan tuomiot</a:t>
+              <a:t>Julkinen riippumaton evidenssikooste · 2026.07.22-8 · 2026-07-22 · Lähteet: Viralliset tuomiot: 8 Ni 18/24 (EP); 7 O 3341/24</a:t>
             </a:r>
           </a:p>
         </p:txBody>
@@ -23101,7 +23335,7 @@
                         </a:defRPr>
                       </a:pPr>
                       <a:r>
-                        <a:t>Ratkaisu</a:t>
+                        <a:t>Viite</a:t>
                       </a:r>
                     </a:p>
                   </a:txBody>
@@ -23125,7 +23359,7 @@
                         </a:defRPr>
                       </a:pPr>
                       <a:r>
-                        <a:t>Vahvistettu</a:t>
+                        <a:t>Virallinen tapahtuma</a:t>
                       </a:r>
                     </a:p>
                   </a:txBody>
@@ -23149,7 +23383,7 @@
                         </a:defRPr>
                       </a:pPr>
                       <a:r>
-                        <a:t>Avoin</a:t>
+                        <a:t>Rajaus ja lopullisuus</a:t>
                       </a:r>
                     </a:p>
                   </a:txBody>
@@ -23199,7 +23433,7 @@
                         </a:defRPr>
                       </a:pPr>
                       <a:r>
-                        <a:t>Mitätöintikanne hylättiin 14.1.2026</a:t>
+                        <a:t>Mitätöintikanne hylättiin; valitus vireillä (14.1.2026)</a:t>
                       </a:r>
                     </a:p>
                   </a:txBody>
@@ -23223,7 +23457,7 @@
                         </a:defRPr>
                       </a:pPr>
                       <a:r>
-                        <a:t>BGH-valitus X ZR 21/26</a:t>
+                        <a:t>Virallinen tuomio hylkäsi EP3032975B2:n Saksan osaa koskevan mitättömyyskanteen. Virallinen rekisteri mainitsee valituksen liittovaltion ylimpään tuomioistuimeen asianumerolla X ZR 21/26. Ei lainvoimainen BGH-valituksen ollessa vireillä.</a:t>
                       </a:r>
                     </a:p>
                   </a:txBody>
@@ -23273,7 +23507,7 @@
                         </a:defRPr>
                       </a:pPr>
                       <a:r>
-                        <a:t>Vaatimusten 1 ja 6 loukkaus tarkastelluissa tuotteissa</a:t>
+                        <a:t>Tarkasteltujen tuotteiden todettiin loukkaavan patenttia (2.4.2026)</a:t>
                       </a:r>
                     </a:p>
                   </a:txBody>
@@ -23297,7 +23531,7 @@
                         </a:defRPr>
                       </a:pPr>
                       <a:r>
-                        <a:t>Valitustila, lainvoima, täytäntöönpano, maksu</a:t>
+                        <a:t>Virallinen tuomio katsoi tarkasteltujen tuotteiden loukkaavan vaatimuksia 1 ja 6 välittömästi ja täydentävien osien osalta välillisesti sekä määräsi tuomiossa luetellut oikeusseuraamukset. Virallinen tuomio on saatavilla; valitustilaa, lainvoimaisuutta ja täytäntöönpanoa ei ole tässä julkaisussa riippumattomasti vahvistettu.</a:t>
                       </a:r>
                     </a:p>
                   </a:txBody>

</xml_diff>

<commit_message>
Add v17 donor market sprint
</commit_message>
<xml_diff>
--- a/site/downloads/pixan-bank-deck-large-fi.pptx
+++ b/site/downloads/pixan-bank-deck-large-fi.pptx
@@ -3386,7 +3386,7 @@
                 </a:solidFill>
                 <a:latin typeface="Aptos"/>
               </a:rPr>
-              <a:t>2026.07.23-16</a:t>
+              <a:t>2026.07.24-17</a:t>
             </a:r>
           </a:p>
         </p:txBody>
@@ -3421,7 +3421,7 @@
                 </a:solidFill>
                 <a:latin typeface="Aptos"/>
               </a:rPr>
-              <a:t>Päivitetty 2026-07-22
+              <a:t>Päivitetty 2026-07-24
 30 diaa · suomeksi</a:t>
             </a:r>
           </a:p>
@@ -3740,7 +3740,7 @@
                 </a:solidFill>
                 <a:latin typeface="Aptos"/>
               </a:rPr>
-              <a:t>Julkinen riippumaton evidenssikooste · 2026.07.23-16 · 2026-07-22 · Lähteet: RPX; CNIPA guidance; EPO family</a:t>
+              <a:t>Julkinen riippumaton evidenssikooste · 2026.07.24-17 · 2026-07-24 · Lähteet: RPX; CNIPA guidance; EPO family</a:t>
             </a:r>
           </a:p>
         </p:txBody>
@@ -4108,7 +4108,7 @@
         </p:nvSpPr>
         <p:spPr>
           <a:xfrm>
-            <a:off x="502920" y="1444752"/>
+            <a:off x="502920" y="1554480"/>
             <a:ext cx="960120" cy="50292"/>
           </a:xfrm>
           <a:prstGeom prst="rect">
@@ -4220,7 +4220,7 @@
                 </a:solidFill>
                 <a:latin typeface="Aptos"/>
               </a:rPr>
-              <a:t>Julkinen riippumaton evidenssikooste · 2026.07.23-16 · 2026-07-22 · Lähteet: IP Australia; PRH; EPO; EPO / UPC; USPTO</a:t>
+              <a:t>Julkinen riippumaton evidenssikooste · 2026.07.24-17 · 2026-07-24 · Lähteet: IP Australia; PRH; EPO; EPO / UPC; USPTO</a:t>
             </a:r>
           </a:p>
         </p:txBody>
@@ -4900,7 +4900,7 @@
                 </a:solidFill>
                 <a:latin typeface="Aptos"/>
               </a:rPr>
-              <a:t>Julkinen riippumaton evidenssikooste · 2026.07.23-16 · 2026-07-22 · Lähteet: UN; Atlas</a:t>
+              <a:t>Julkinen riippumaton evidenssikooste · 2026.07.24-17 · 2026-07-24 · Lähteet: UN; Atlas</a:t>
             </a:r>
           </a:p>
         </p:txBody>
@@ -5622,7 +5622,7 @@
         <p:spPr>
           <a:xfrm>
             <a:off x="502920" y="621792"/>
-            <a:ext cx="11109960" cy="548640"/>
+            <a:ext cx="11109960" cy="804672"/>
           </a:xfrm>
           <a:prstGeom prst="rect">
             <a:avLst/>
@@ -5637,13 +5637,13 @@
           <a:p>
             <a:pPr algn="l"/>
             <a:r>
-              <a:rPr sz="3400" b="1">
+              <a:rPr sz="3000" b="1">
                 <a:solidFill>
                   <a:srgbClr val="071A2B"/>
                 </a:solidFill>
                 <a:latin typeface="Aptos"/>
               </a:rPr>
-              <a:t>Viralliset havainnot 5 maasta mittaavat eri asioita</a:t>
+              <a:t>20 virallista havaintoa 6 maasta mittaavat eri asioita</a:t>
             </a:r>
           </a:p>
         </p:txBody>
@@ -5656,7 +5656,7 @@
         </p:nvSpPr>
         <p:spPr>
           <a:xfrm>
-            <a:off x="502920" y="1225296"/>
+            <a:off x="502920" y="1554480"/>
             <a:ext cx="960120" cy="50292"/>
           </a:xfrm>
           <a:prstGeom prst="rect">
@@ -5768,7 +5768,7 @@
                 </a:solidFill>
                 <a:latin typeface="Aptos"/>
               </a:rPr>
-              <a:t>Julkinen riippumaton evidenssikooste · 2026.07.23-16 · 2026-07-22 · Lähteet: Health Canada; Destatis; Vero; Sejm; Ruotsin hallitus</a:t>
+              <a:t>Julkinen riippumaton evidenssikooste · 2026.07.24-17 · 2026-07-24 · Lähteet: Health Canada; New Zealand Ministry of Health; Destatis; Vero; Sejm; Ruotsin hallitus</a:t>
             </a:r>
           </a:p>
         </p:txBody>
@@ -5817,8 +5817,8 @@
           <p:nvPr/>
         </p:nvGraphicFramePr>
         <p:xfrm>
-          <a:off x="530352" y="1536192"/>
-          <a:ext cx="11109960" cy="3977637"/>
+          <a:off x="530352" y="1719072"/>
+          <a:ext cx="11109960" cy="3794760"/>
         </p:xfrm>
         <a:graphic>
           <a:graphicData uri="http://schemas.openxmlformats.org/drawingml/2006/table">
@@ -5905,7 +5905,7 @@
                   </a:tcPr>
                 </a:tc>
               </a:tr>
-              <a:tr h="707745">
+              <a:tr h="559308">
                 <a:tc>
                   <a:txBody>
                     <a:bodyPr/>
@@ -5979,7 +5979,7 @@
                   </a:tcPr>
                 </a:tc>
               </a:tr>
-              <a:tr h="707745">
+              <a:tr h="559308">
                 <a:tc>
                   <a:txBody>
                     <a:bodyPr/>
@@ -6053,7 +6053,7 @@
                   </a:tcPr>
                 </a:tc>
               </a:tr>
-              <a:tr h="707745">
+              <a:tr h="559308">
                 <a:tc>
                   <a:txBody>
                     <a:bodyPr/>
@@ -6127,7 +6127,7 @@
                   </a:tcPr>
                 </a:tc>
               </a:tr>
-              <a:tr h="707745">
+              <a:tr h="559308">
                 <a:tc>
                   <a:txBody>
                     <a:bodyPr/>
@@ -6142,7 +6142,7 @@
                         </a:defRPr>
                       </a:pPr>
                       <a:r>
-                        <a:t>Puola</a:t>
+                        <a:t>Uusi-Seelanti</a:t>
                       </a:r>
                     </a:p>
                   </a:txBody>
@@ -6166,7 +6166,7 @@
                         </a:defRPr>
                       </a:pPr>
                       <a:r>
-                        <a:t>2023 / 2025</a:t>
+                        <a:t>2022–2024</a:t>
                       </a:r>
                     </a:p>
                   </a:txBody>
@@ -6190,7 +6190,7 @@
                         </a:defRPr>
                       </a:pPr>
                       <a:r>
-                        <a:t>805 441 l; 993,1 milj. PLN valmisteveroa</a:t>
+                        <a:t>otsikko vähintään 280 milj. NZD; 280,685 milj. NZD 29 tiedoston raakasumma; 264,561 milj. NZD toistorivien poistamisen herkkyys, ei korjattu estimaatti</a:t>
                       </a:r>
                     </a:p>
                   </a:txBody>
@@ -6201,7 +6201,7 @@
                   </a:tcPr>
                 </a:tc>
               </a:tr>
-              <a:tr h="707745">
+              <a:tr h="559308">
                 <a:tc>
                   <a:txBody>
                     <a:bodyPr/>
@@ -6216,7 +6216,7 @@
                         </a:defRPr>
                       </a:pPr>
                       <a:r>
-                        <a:t>Ruotsi</a:t>
+                        <a:t>Puola</a:t>
                       </a:r>
                     </a:p>
                   </a:txBody>
@@ -6240,7 +6240,7 @@
                         </a:defRPr>
                       </a:pPr>
                       <a:r>
-                        <a:t>2024</a:t>
+                        <a:t>2023 / 2025</a:t>
                       </a:r>
                     </a:p>
                   </a:txBody>
@@ -6264,13 +6264,87 @@
                         </a:defRPr>
                       </a:pPr>
                       <a:r>
+                        <a:t>805 441 l; 993,1 milj. PLN valmisteveroa</a:t>
+                      </a:r>
+                    </a:p>
+                  </a:txBody>
+                  <a:tcPr marL="73152" marR="73152" marT="36576" marB="36576">
+                    <a:solidFill>
+                      <a:srgbClr val="FFFFFF"/>
+                    </a:solidFill>
+                  </a:tcPr>
+                </a:tc>
+              </a:tr>
+              <a:tr h="559308">
+                <a:tc>
+                  <a:txBody>
+                    <a:bodyPr/>
+                    <a:lstStyle/>
+                    <a:p>
+                      <a:pPr algn="l">
+                        <a:defRPr sz="1320">
+                          <a:solidFill>
+                            <a:srgbClr val="182935"/>
+                          </a:solidFill>
+                          <a:latin typeface="Aptos"/>
+                        </a:defRPr>
+                      </a:pPr>
+                      <a:r>
+                        <a:t>Ruotsi</a:t>
+                      </a:r>
+                    </a:p>
+                  </a:txBody>
+                  <a:tcPr marL="73152" marR="73152" marT="36576" marB="36576">
+                    <a:solidFill>
+                      <a:srgbClr val="F6F9FA"/>
+                    </a:solidFill>
+                  </a:tcPr>
+                </a:tc>
+                <a:tc>
+                  <a:txBody>
+                    <a:bodyPr/>
+                    <a:lstStyle/>
+                    <a:p>
+                      <a:pPr algn="l">
+                        <a:defRPr sz="1320">
+                          <a:solidFill>
+                            <a:srgbClr val="182935"/>
+                          </a:solidFill>
+                          <a:latin typeface="Aptos"/>
+                        </a:defRPr>
+                      </a:pPr>
+                      <a:r>
+                        <a:t>2024</a:t>
+                      </a:r>
+                    </a:p>
+                  </a:txBody>
+                  <a:tcPr marL="73152" marR="73152" marT="36576" marB="36576">
+                    <a:solidFill>
+                      <a:srgbClr val="F6F9FA"/>
+                    </a:solidFill>
+                  </a:tcPr>
+                </a:tc>
+                <a:tc>
+                  <a:txBody>
+                    <a:bodyPr/>
+                    <a:lstStyle/>
+                    <a:p>
+                      <a:pPr algn="l">
+                        <a:defRPr sz="1320">
+                          <a:solidFill>
+                            <a:srgbClr val="182935"/>
+                          </a:solidFill>
+                          <a:latin typeface="Aptos"/>
+                        </a:defRPr>
+                      </a:pPr>
+                      <a:r>
                         <a:t>26 000 l; 80 milj. SEK valmisteveroa</a:t>
                       </a:r>
                     </a:p>
                   </a:txBody>
                   <a:tcPr marL="73152" marR="73152" marT="36576" marB="36576">
                     <a:solidFill>
-                      <a:srgbClr val="FFFFFF"/>
+                      <a:srgbClr val="F6F9FA"/>
                     </a:solidFill>
                   </a:tcPr>
                 </a:tc>
@@ -6522,7 +6596,7 @@
                 </a:solidFill>
                 <a:latin typeface="Aptos"/>
               </a:rPr>
-              <a:t>Julkinen riippumaton evidenssikooste · 2026.07.23-16 · 2026-07-22 · Lähteet: Health Canada 2024</a:t>
+              <a:t>Julkinen riippumaton evidenssikooste · 2026.07.24-17 · 2026-07-24 · Lähteet: Health Canada 2024</a:t>
             </a:r>
           </a:p>
         </p:txBody>
@@ -7161,7 +7235,7 @@
         </p:nvSpPr>
         <p:spPr>
           <a:xfrm>
-            <a:off x="502920" y="1444752"/>
+            <a:off x="502920" y="1554480"/>
             <a:ext cx="960120" cy="50292"/>
           </a:xfrm>
           <a:prstGeom prst="rect">
@@ -7273,7 +7347,7 @@
                 </a:solidFill>
                 <a:latin typeface="Aptos"/>
               </a:rPr>
-              <a:t>Julkinen riippumaton evidenssikooste · 2026.07.23-16 · 2026-07-22 · Lähteet: Destatis</a:t>
+              <a:t>Julkinen riippumaton evidenssikooste · 2026.07.24-17 · 2026-07-24 · Lähteet: Destatis</a:t>
             </a:r>
           </a:p>
         </p:txBody>
@@ -7976,7 +8050,7 @@
                 </a:solidFill>
                 <a:latin typeface="Aptos"/>
               </a:rPr>
-              <a:t>Julkinen riippumaton evidenssikooste · 2026.07.23-16 · 2026-07-22 · Lähteet: Destatis; inTaste.de</a:t>
+              <a:t>Julkinen riippumaton evidenssikooste · 2026.07.24-17 · 2026-07-24 · Lähteet: Destatis; inTaste.de</a:t>
             </a:r>
           </a:p>
         </p:txBody>
@@ -8727,7 +8801,7 @@
                 </a:solidFill>
                 <a:latin typeface="Aptos"/>
               </a:rPr>
-              <a:t>Julkinen riippumaton evidenssikooste · 2026.07.23-16 · 2026-07-22 · Lähteet: IMARC; GVR; Fortune</a:t>
+              <a:t>Julkinen riippumaton evidenssikooste · 2026.07.24-17 · 2026-07-24 · Lähteet: IMARC; GVR; Fortune; European Commission</a:t>
             </a:r>
           </a:p>
         </p:txBody>
@@ -8776,7 +8850,7 @@
         <p:spPr>
           <a:xfrm>
             <a:off x="530352" y="1719072"/>
-            <a:ext cx="3532632" cy="1371600"/>
+            <a:ext cx="2585466" cy="1371600"/>
           </a:xfrm>
           <a:prstGeom prst="roundRect">
             <a:avLst>
@@ -8823,7 +8897,7 @@
         <p:spPr>
           <a:xfrm>
             <a:off x="694944" y="1883664"/>
-            <a:ext cx="3203448" cy="530352"/>
+            <a:ext cx="2256282" cy="530352"/>
           </a:xfrm>
           <a:prstGeom prst="rect">
             <a:avLst/>
@@ -8858,7 +8932,7 @@
         <p:spPr>
           <a:xfrm>
             <a:off x="694944" y="2468879"/>
-            <a:ext cx="3203448" cy="438912"/>
+            <a:ext cx="2256282" cy="438912"/>
           </a:xfrm>
           <a:prstGeom prst="rect">
             <a:avLst/>
@@ -8892,8 +8966,8 @@
         </p:nvSpPr>
         <p:spPr>
           <a:xfrm>
-            <a:off x="4319016" y="1719072"/>
-            <a:ext cx="3532632" cy="1371600"/>
+            <a:off x="3371850" y="1719072"/>
+            <a:ext cx="2585466" cy="1371600"/>
           </a:xfrm>
           <a:prstGeom prst="roundRect">
             <a:avLst>
@@ -8939,8 +9013,8 @@
         </p:nvSpPr>
         <p:spPr>
           <a:xfrm>
-            <a:off x="4483608" y="1883664"/>
-            <a:ext cx="3203448" cy="530352"/>
+            <a:off x="3536442" y="1883664"/>
+            <a:ext cx="2256282" cy="530352"/>
           </a:xfrm>
           <a:prstGeom prst="rect">
             <a:avLst/>
@@ -8974,8 +9048,8 @@
         </p:nvSpPr>
         <p:spPr>
           <a:xfrm>
-            <a:off x="4483608" y="2468879"/>
-            <a:ext cx="3203448" cy="438912"/>
+            <a:off x="3536442" y="2468879"/>
+            <a:ext cx="2256282" cy="438912"/>
           </a:xfrm>
           <a:prstGeom prst="rect">
             <a:avLst/>
@@ -9009,8 +9083,8 @@
         </p:nvSpPr>
         <p:spPr>
           <a:xfrm>
-            <a:off x="8107680" y="1719072"/>
-            <a:ext cx="3532632" cy="1371600"/>
+            <a:off x="6213348" y="1719072"/>
+            <a:ext cx="2585466" cy="1371600"/>
           </a:xfrm>
           <a:prstGeom prst="roundRect">
             <a:avLst>
@@ -9056,8 +9130,8 @@
         </p:nvSpPr>
         <p:spPr>
           <a:xfrm>
-            <a:off x="8272272" y="1883664"/>
-            <a:ext cx="3203448" cy="530352"/>
+            <a:off x="6377940" y="1883664"/>
+            <a:ext cx="2256282" cy="530352"/>
           </a:xfrm>
           <a:prstGeom prst="rect">
             <a:avLst/>
@@ -9091,8 +9165,8 @@
         </p:nvSpPr>
         <p:spPr>
           <a:xfrm>
-            <a:off x="8272272" y="2468879"/>
-            <a:ext cx="3203448" cy="438912"/>
+            <a:off x="6377940" y="2468879"/>
+            <a:ext cx="2256282" cy="438912"/>
           </a:xfrm>
           <a:prstGeom prst="rect">
             <a:avLst/>
@@ -9120,7 +9194,124 @@
       </p:sp>
       <p:sp>
         <p:nvSpPr>
-          <p:cNvPr id="17" name="TextBox 16"/>
+          <p:cNvPr id="17" name="Rounded Rectangle 16"/>
+          <p:cNvSpPr/>
+          <p:nvPr/>
+        </p:nvSpPr>
+        <p:spPr>
+          <a:xfrm>
+            <a:off x="9054846" y="1719072"/>
+            <a:ext cx="2585466" cy="1371600"/>
+          </a:xfrm>
+          <a:prstGeom prst="roundRect">
+            <a:avLst>
+              <a:gd name="adj" fmla="val 8000"/>
+            </a:avLst>
+          </a:prstGeom>
+          <a:solidFill>
+            <a:srgbClr val="F6F9FA"/>
+          </a:solidFill>
+          <a:ln>
+            <a:solidFill>
+              <a:srgbClr val="CBD8DE"/>
+            </a:solidFill>
+          </a:ln>
+        </p:spPr>
+        <p:style>
+          <a:lnRef idx="1">
+            <a:schemeClr val="accent1"/>
+          </a:lnRef>
+          <a:fillRef idx="3">
+            <a:schemeClr val="accent1"/>
+          </a:fillRef>
+          <a:effectRef idx="2">
+            <a:schemeClr val="accent1"/>
+          </a:effectRef>
+          <a:fontRef idx="minor">
+            <a:schemeClr val="lt1"/>
+          </a:fontRef>
+        </p:style>
+        <p:txBody>
+          <a:bodyPr rtlCol="0" anchor="ctr"/>
+          <a:lstStyle/>
+          <a:p>
+            <a:pPr algn="ctr"/>
+          </a:p>
+        </p:txBody>
+      </p:sp>
+      <p:sp>
+        <p:nvSpPr>
+          <p:cNvPr id="18" name="TextBox 17"/>
+          <p:cNvSpPr txBox="1"/>
+          <p:nvPr/>
+        </p:nvSpPr>
+        <p:spPr>
+          <a:xfrm>
+            <a:off x="9219438" y="1883664"/>
+            <a:ext cx="2256282" cy="530352"/>
+          </a:xfrm>
+          <a:prstGeom prst="rect">
+            <a:avLst/>
+          </a:prstGeom>
+          <a:noFill/>
+        </p:spPr>
+        <p:txBody>
+          <a:bodyPr wrap="square" lIns="36576" rIns="36576" tIns="36576" bIns="36576" anchor="t">
+            <a:spAutoFit/>
+          </a:bodyPr>
+          <a:lstStyle/>
+          <a:p>
+            <a:pPr algn="l"/>
+            <a:r>
+              <a:rPr sz="2700" b="1">
+                <a:solidFill>
+                  <a:srgbClr val="138A72"/>
+                </a:solidFill>
+                <a:latin typeface="Aptos"/>
+              </a:rPr>
+              <a:t>4,99 mrd EUR</a:t>
+            </a:r>
+          </a:p>
+        </p:txBody>
+      </p:sp>
+      <p:sp>
+        <p:nvSpPr>
+          <p:cNvPr id="19" name="TextBox 18"/>
+          <p:cNvSpPr txBox="1"/>
+          <p:nvPr/>
+        </p:nvSpPr>
+        <p:spPr>
+          <a:xfrm>
+            <a:off x="9219438" y="2468879"/>
+            <a:ext cx="2256282" cy="438912"/>
+          </a:xfrm>
+          <a:prstGeom prst="rect">
+            <a:avLst/>
+          </a:prstGeom>
+          <a:noFill/>
+        </p:spPr>
+        <p:txBody>
+          <a:bodyPr wrap="square" lIns="36576" rIns="36576" tIns="36576" bIns="36576" anchor="t">
+            <a:spAutoFit/>
+          </a:bodyPr>
+          <a:lstStyle/>
+          <a:p>
+            <a:pPr algn="l"/>
+            <a:r>
+              <a:rPr sz="1400" b="0">
+                <a:solidFill>
+                  <a:srgbClr val="5B6B75"/>
+                </a:solidFill>
+                <a:latin typeface="Aptos"/>
+              </a:rPr>
+              <a:t>EU-komission vertailuarvo 2023</a:t>
+            </a:r>
+          </a:p>
+        </p:txBody>
+      </p:sp>
+      <p:sp>
+        <p:nvSpPr>
+          <p:cNvPr id="20" name="TextBox 19"/>
           <p:cNvSpPr txBox="1"/>
           <p:nvPr/>
         </p:nvSpPr>
@@ -9148,14 +9339,14 @@
                 </a:solidFill>
                 <a:latin typeface="Aptos"/>
               </a:rPr>
-              <a:t>Haarukka on leveä, koska tuoterajaukset ja metodit voivat poiketa.</a:t>
-            </a:r>
-          </a:p>
-        </p:txBody>
-      </p:sp>
-      <p:sp>
-        <p:nvSpPr>
-          <p:cNvPr id="18" name="Rounded Rectangle 17"/>
+              <a:t>EU:n vertailuarvo tukee mittaluokan ristiintarkistusta; kaupallinen haarukka on leveä, koska tuoterajaukset ja metodit voivat poiketa.</a:t>
+            </a:r>
+          </a:p>
+        </p:txBody>
+      </p:sp>
+      <p:sp>
+        <p:nvSpPr>
+          <p:cNvPr id="21" name="Rounded Rectangle 20"/>
           <p:cNvSpPr/>
           <p:nvPr/>
         </p:nvSpPr>
@@ -9202,7 +9393,7 @@
       </p:sp>
       <p:sp>
         <p:nvSpPr>
-          <p:cNvPr id="19" name="TextBox 18"/>
+          <p:cNvPr id="22" name="TextBox 21"/>
           <p:cNvSpPr txBox="1"/>
           <p:nvPr/>
         </p:nvSpPr>
@@ -9237,7 +9428,7 @@
       </p:sp>
       <p:sp>
         <p:nvSpPr>
-          <p:cNvPr id="20" name="TextBox 19"/>
+          <p:cNvPr id="23" name="TextBox 22"/>
           <p:cNvSpPr txBox="1"/>
           <p:nvPr/>
         </p:nvSpPr>
@@ -9265,7 +9456,7 @@
                 </a:solidFill>
                 <a:latin typeface="Aptos"/>
               </a:rPr>
-              <a:t>Arvioita verrataan keskenään. Niitä ei summata, eikä haarukkaa käytetä automaattisesti rojaltipohjana.</a:t>
+              <a:t>EU-luku perustuu kaupalliseen Euromonitor 2025 -aineistoon; Kypros, Luxemburg ja Malta puuttuvat. Se ei ole kansallinen luovuttajamarkkina. Arvioita verrataan, ei summata tai käytetä automaattisesti rojaltipohjana.</a:t>
             </a:r>
           </a:p>
         </p:txBody>
@@ -9478,7 +9669,7 @@
                 </a:solidFill>
                 <a:latin typeface="Aptos"/>
               </a:rPr>
-              <a:t>Julkinen riippumaton evidenssikooste · 2026.07.23-16 · 2026-07-22 · Lähteet: Market-values modelReadiness</a:t>
+              <a:t>Julkinen riippumaton evidenssikooste · 2026.07.24-17 · 2026-07-24 · Lähteet: Market-values modelReadiness, donorProtocol ja donorCandidates</a:t>
             </a:r>
           </a:p>
         </p:txBody>
@@ -9548,7 +9739,7 @@
                 </a:solidFill>
                 <a:latin typeface="Aptos"/>
               </a:rPr>
-              <a:t>Nykyinen comparable consumer-retail donor count on 0; hard gate ei täyty.</a:t>
+              <a:t>Nykyinen hyväksytty donor-portti on 0/3; kaikki 4 ehdokasta jäivät ulkopuolelle.</a:t>
             </a:r>
           </a:p>
         </p:txBody>
@@ -9590,7 +9781,7 @@
               </a:defRPr>
             </a:pPr>
             <a:r>
-              <a:t>•  Sama tuoterajaus ja kalenterivuosi.</a:t>
+              <a:t>•  Jokaisen ehdokkaan on läpäistävä kaikki 10 ehtoa (D1–D10).</a:t>
             </a:r>
           </a:p>
           <a:p>
@@ -9609,7 +9800,7 @@
               </a:defRPr>
             </a:pPr>
             <a:r>
-              <a:t>•  Kuluttajavähittäisarvo, ei toimitus-, vero- tai volyymiproxy.</a:t>
+              <a:t>•  Uusi-Seelantin 280,685 milj. NZD raakasumma ja 264,561 milj. NZD toistoriviherkkyys eivät ole puhdistettu estimaatti; EU:n vertailuarvo, Kanadan toimitusproxy ja Saksan nestemalli hylättiin myös luovuttajina.</a:t>
             </a:r>
           </a:p>
           <a:p>
@@ -9628,7 +9819,7 @@
               </a:defRPr>
             </a:pPr>
             <a:r>
-              <a:t>•  Alue- ja sääntelytyyppien peitto sekä suora validointi suurissa talouksissa.</a:t>
+              <a:t>•  Alue- ja sääntelytyyppien peitto sekä suora validointi suurissa talouksissa vaaditaan vielä.</a:t>
             </a:r>
           </a:p>
         </p:txBody>
@@ -9846,7 +10037,7 @@
         </p:nvSpPr>
         <p:spPr>
           <a:xfrm>
-            <a:off x="502920" y="1444752"/>
+            <a:off x="502920" y="1554480"/>
             <a:ext cx="960120" cy="50292"/>
           </a:xfrm>
           <a:prstGeom prst="rect">
@@ -9958,7 +10149,7 @@
                 </a:solidFill>
                 <a:latin typeface="Aptos"/>
               </a:rPr>
-              <a:t>Julkinen riippumaton evidenssikooste · 2026.07.23-16 · 2026-07-22 · Lähteet: WIPO valuation; Evidence Register</a:t>
+              <a:t>Julkinen riippumaton evidenssikooste · 2026.07.24-17 · 2026-07-24 · Lähteet: WIPO valuation; Evidence Register</a:t>
             </a:r>
           </a:p>
         </p:txBody>
@@ -10712,7 +10903,7 @@
                 </a:solidFill>
                 <a:latin typeface="Aptos"/>
               </a:rPr>
-              <a:t>Julkinen riippumaton evidenssikooste · 2026.07.23-16 · 2026-07-22 · Lähteet: EPO; Saksa — viralliset tuomiot; WIPO</a:t>
+              <a:t>Julkinen riippumaton evidenssikooste · 2026.07.24-17 · 2026-07-24 · Lähteet: EPO; Saksa — viralliset tuomiot; WIPO</a:t>
             </a:r>
           </a:p>
         </p:txBody>
@@ -10843,7 +11034,7 @@
               </a:defRPr>
             </a:pPr>
             <a:r>
-              <a:t>•  Markkina-aineisto kattaa 195 maan tutkimusrungon, mutta yhteismitallisia retail-luovuttajia on 0.</a:t>
+              <a:t>•  Markkina-aineistossa on 20 virallista vuosihavaintoa 6 maasta, mutta luovuttajaportti on 0/3.</a:t>
             </a:r>
           </a:p>
           <a:p>
@@ -11192,7 +11383,7 @@
                 </a:solidFill>
                 <a:latin typeface="Aptos"/>
               </a:rPr>
-              <a:t>Julkinen riippumaton evidenssikooste · 2026.07.23-16 · 2026-07-22 · Lähteet: WIPO licensing; IP Finance</a:t>
+              <a:t>Julkinen riippumaton evidenssikooste · 2026.07.24-17 · 2026-07-24 · Lähteet: WIPO licensing; IP Finance</a:t>
             </a:r>
           </a:p>
         </p:txBody>
@@ -11560,7 +11751,7 @@
         </p:nvSpPr>
         <p:spPr>
           <a:xfrm>
-            <a:off x="502920" y="1444752"/>
+            <a:off x="502920" y="1554480"/>
             <a:ext cx="960120" cy="50292"/>
           </a:xfrm>
           <a:prstGeom prst="rect">
@@ -11672,7 +11863,7 @@
                 </a:solidFill>
                 <a:latin typeface="Aptos"/>
               </a:rPr>
-              <a:t>Julkinen riippumaton evidenssikooste · 2026.07.23-16 · 2026-07-22 · Lähteet: Evidence Register; EPO</a:t>
+              <a:t>Julkinen riippumaton evidenssikooste · 2026.07.24-17 · 2026-07-24 · Lähteet: Evidence Register; EPO</a:t>
             </a:r>
           </a:p>
         </p:txBody>
@@ -12352,7 +12543,7 @@
                 </a:solidFill>
                 <a:latin typeface="Aptos"/>
               </a:rPr>
-              <a:t>Julkinen riippumaton evidenssikooste · 2026.07.23-16 · 2026-07-22 · Lähteet: EP3032975B2; 7 O 3341/24</a:t>
+              <a:t>Julkinen riippumaton evidenssikooste · 2026.07.24-17 · 2026-07-24 · Lähteet: EP3032975B2; 7 O 3341/24</a:t>
             </a:r>
           </a:p>
         </p:txBody>
@@ -13243,7 +13434,7 @@
                 </a:solidFill>
                 <a:latin typeface="Aptos"/>
               </a:rPr>
-              <a:t>Julkinen riippumaton evidenssikooste · 2026.07.23-16 · 2026-07-22 · Lähteet: WIPO dispute resolution; EPO IPscore</a:t>
+              <a:t>Julkinen riippumaton evidenssikooste · 2026.07.24-17 · 2026-07-24 · Lähteet: WIPO dispute resolution; EPO IPscore</a:t>
             </a:r>
           </a:p>
         </p:txBody>
@@ -14022,7 +14213,7 @@
         </p:nvSpPr>
         <p:spPr>
           <a:xfrm>
-            <a:off x="502920" y="1444752"/>
+            <a:off x="502920" y="1554480"/>
             <a:ext cx="960120" cy="50292"/>
           </a:xfrm>
           <a:prstGeom prst="rect">
@@ -14134,7 +14325,7 @@
                 </a:solidFill>
                 <a:latin typeface="Aptos"/>
               </a:rPr>
-              <a:t>Julkinen riippumaton evidenssikooste · 2026.07.23-16 · 2026-07-22 · Lähteet: WIPO licensing; IP Finance; TPLF mapping</a:t>
+              <a:t>Julkinen riippumaton evidenssikooste · 2026.07.24-17 · 2026-07-24 · Lähteet: WIPO licensing; IP Finance; TPLF mapping</a:t>
             </a:r>
           </a:p>
         </p:txBody>
@@ -14888,7 +15079,7 @@
                 </a:solidFill>
                 <a:latin typeface="Aptos"/>
               </a:rPr>
-              <a:t>Julkinen riippumaton evidenssikooste · 2026.07.23-16 · 2026-07-22 · Lähteet: Evidence Register; WIPO valuation</a:t>
+              <a:t>Julkinen riippumaton evidenssikooste · 2026.07.24-17 · 2026-07-24 · Lähteet: Evidence Register; WIPO valuation</a:t>
             </a:r>
           </a:p>
         </p:txBody>
@@ -15716,7 +15907,7 @@
                 </a:solidFill>
                 <a:latin typeface="Aptos"/>
               </a:rPr>
-              <a:t>Julkinen riippumaton evidenssikooste · 2026.07.23-16 · 2026-07-22 · Lähteet: WIPO valuation</a:t>
+              <a:t>Julkinen riippumaton evidenssikooste · 2026.07.24-17 · 2026-07-24 · Lähteet: WIPO valuation</a:t>
             </a:r>
           </a:p>
         </p:txBody>
@@ -16503,7 +16694,7 @@
         </p:nvSpPr>
         <p:spPr>
           <a:xfrm>
-            <a:off x="502920" y="1444752"/>
+            <a:off x="502920" y="1554480"/>
             <a:ext cx="960120" cy="50292"/>
           </a:xfrm>
           <a:prstGeom prst="rect">
@@ -16615,7 +16806,7 @@
                 </a:solidFill>
                 <a:latin typeface="Aptos"/>
               </a:rPr>
-              <a:t>Julkinen riippumaton evidenssikooste · 2026.07.23-16 · 2026-07-22 · Lähteet: Evidence Register</a:t>
+              <a:t>Julkinen riippumaton evidenssikooste · 2026.07.24-17 · 2026-07-24 · Lähteet: Evidence Register</a:t>
             </a:r>
           </a:p>
         </p:txBody>
@@ -17257,7 +17448,7 @@
         </p:nvSpPr>
         <p:spPr>
           <a:xfrm>
-            <a:off x="502920" y="1444752"/>
+            <a:off x="502920" y="1554480"/>
             <a:ext cx="960120" cy="50292"/>
           </a:xfrm>
           <a:prstGeom prst="rect">
@@ -17369,7 +17560,7 @@
                 </a:solidFill>
                 <a:latin typeface="Aptos"/>
               </a:rPr>
-              <a:t>Julkinen riippumaton evidenssikooste · 2026.07.23-16 · 2026-07-22 · Lähteet: Evidence Register</a:t>
+              <a:t>Julkinen riippumaton evidenssikooste · 2026.07.24-17 · 2026-07-24 · Lähteet: Evidence Register</a:t>
             </a:r>
           </a:p>
         </p:txBody>
@@ -18197,7 +18388,7 @@
                 </a:solidFill>
                 <a:latin typeface="Aptos"/>
               </a:rPr>
-              <a:t>Julkinen riippumaton evidenssikooste · 2026.07.23-16 · 2026-07-22 · Lähteet: Evidence Register; changelog</a:t>
+              <a:t>Julkinen riippumaton evidenssikooste · 2026.07.24-17 · 2026-07-24 · Lähteet: Evidence Register; changelog</a:t>
             </a:r>
           </a:p>
         </p:txBody>
@@ -18976,7 +19167,7 @@
         </p:nvSpPr>
         <p:spPr>
           <a:xfrm>
-            <a:off x="502920" y="1444752"/>
+            <a:off x="502920" y="1554480"/>
             <a:ext cx="960120" cy="50292"/>
           </a:xfrm>
           <a:prstGeom prst="rect">
@@ -19088,7 +19279,7 @@
                 </a:solidFill>
                 <a:latin typeface="Aptos"/>
               </a:rPr>
-              <a:t>Julkinen riippumaton evidenssikooste · 2026.07.23-16 · 2026-07-22 · Lähteet: EPO; 8 Ni 18/24 (EP); 7 O 3341/24</a:t>
+              <a:t>Julkinen riippumaton evidenssikooste · 2026.07.24-17 · 2026-07-24 · Lähteet: EPO; 8 Ni 18/24 (EP); 7 O 3341/24</a:t>
             </a:r>
           </a:p>
         </p:txBody>
@@ -19711,7 +19902,7 @@
                 </a:solidFill>
                 <a:latin typeface="Aptos"/>
               </a:rPr>
-              <a:t>Versio 2026.07.23-16 · 2026-07-22 · 30 / 30</a:t>
+              <a:t>Versio 2026.07.24-17 · 2026-07-24 · 30 / 30</a:t>
             </a:r>
           </a:p>
         </p:txBody>
@@ -19924,7 +20115,7 @@
                 </a:solidFill>
                 <a:latin typeface="Aptos"/>
               </a:rPr>
-              <a:t>Julkinen riippumaton evidenssikooste · 2026.07.23-16 · 2026-07-22 · Lähteet: Evidence Register; WIPO</a:t>
+              <a:t>Julkinen riippumaton evidenssikooste · 2026.07.24-17 · 2026-07-24 · Lähteet: Evidence Register; WIPO</a:t>
             </a:r>
           </a:p>
         </p:txBody>
@@ -20404,7 +20595,7 @@
                 </a:solidFill>
                 <a:latin typeface="Aptos"/>
               </a:rPr>
-              <a:t>Julkinen riippumaton evidenssikooste · 2026.07.23-16 · 2026-07-22 · Lähteet: EP3032975B2</a:t>
+              <a:t>Julkinen riippumaton evidenssikooste · 2026.07.24-17 · 2026-07-24 · Lähteet: EP3032975B2</a:t>
             </a:r>
           </a:p>
         </p:txBody>
@@ -20772,7 +20963,7 @@
         </p:nvSpPr>
         <p:spPr>
           <a:xfrm>
-            <a:off x="502920" y="1444752"/>
+            <a:off x="502920" y="1554480"/>
             <a:ext cx="960120" cy="50292"/>
           </a:xfrm>
           <a:prstGeom prst="rect">
@@ -20884,7 +21075,7 @@
                 </a:solidFill>
                 <a:latin typeface="Aptos"/>
               </a:rPr>
-              <a:t>Julkinen riippumaton evidenssikooste · 2026.07.23-16 · 2026-07-22 · Lähteet: EP3032975B2</a:t>
+              <a:t>Julkinen riippumaton evidenssikooste · 2026.07.24-17 · 2026-07-24 · Lähteet: EP3032975B2</a:t>
             </a:r>
           </a:p>
         </p:txBody>
@@ -21638,7 +21829,7 @@
                 </a:solidFill>
                 <a:latin typeface="Aptos"/>
               </a:rPr>
-              <a:t>Julkinen riippumaton evidenssikooste · 2026.07.23-16 · 2026-07-22 · Lähteet: EPO Register; B2</a:t>
+              <a:t>Julkinen riippumaton evidenssikooste · 2026.07.24-17 · 2026-07-24 · Lähteet: EPO Register; B2</a:t>
             </a:r>
           </a:p>
         </p:txBody>
@@ -22389,7 +22580,7 @@
                 </a:solidFill>
                 <a:latin typeface="Aptos"/>
               </a:rPr>
-              <a:t>Julkinen riippumaton evidenssikooste · 2026.07.23-16 · 2026-07-22 · Lähteet: EPO family; kansalliset rekisterit</a:t>
+              <a:t>Julkinen riippumaton evidenssikooste · 2026.07.24-17 · 2026-07-24 · Lähteet: EPO family; kansalliset rekisterit</a:t>
             </a:r>
           </a:p>
         </p:txBody>
@@ -23145,7 +23336,7 @@
         </p:nvSpPr>
         <p:spPr>
           <a:xfrm>
-            <a:off x="502920" y="1444752"/>
+            <a:off x="502920" y="1554480"/>
             <a:ext cx="960120" cy="50292"/>
           </a:xfrm>
           <a:prstGeom prst="rect">
@@ -23257,7 +23448,7 @@
                 </a:solidFill>
                 <a:latin typeface="Aptos"/>
               </a:rPr>
-              <a:t>Julkinen riippumaton evidenssikooste · 2026.07.23-16 · 2026-07-22 · Lähteet: Viralliset tuomiot: 8 Ni 18/24 (EP); 7 O 3341/24</a:t>
+              <a:t>Julkinen riippumaton evidenssikooste · 2026.07.24-17 · 2026-07-24 · Lähteet: Viralliset tuomiot: 8 Ni 18/24 (EP); 7 O 3341/24</a:t>
             </a:r>
           </a:p>
         </p:txBody>

</xml_diff>

<commit_message>
Add v17 donor market sprint (#15)
Co-authored-by: jounirautio78-ops <jounirautio78-ops@users.noreply.github.com>
</commit_message>
<xml_diff>
--- a/site/downloads/pixan-bank-deck-large-fi.pptx
+++ b/site/downloads/pixan-bank-deck-large-fi.pptx
@@ -3386,7 +3386,7 @@
                 </a:solidFill>
                 <a:latin typeface="Aptos"/>
               </a:rPr>
-              <a:t>2026.07.23-16</a:t>
+              <a:t>2026.07.24-17</a:t>
             </a:r>
           </a:p>
         </p:txBody>
@@ -3421,7 +3421,7 @@
                 </a:solidFill>
                 <a:latin typeface="Aptos"/>
               </a:rPr>
-              <a:t>Päivitetty 2026-07-22
+              <a:t>Päivitetty 2026-07-24
 30 diaa · suomeksi</a:t>
             </a:r>
           </a:p>
@@ -3740,7 +3740,7 @@
                 </a:solidFill>
                 <a:latin typeface="Aptos"/>
               </a:rPr>
-              <a:t>Julkinen riippumaton evidenssikooste · 2026.07.23-16 · 2026-07-22 · Lähteet: RPX; CNIPA guidance; EPO family</a:t>
+              <a:t>Julkinen riippumaton evidenssikooste · 2026.07.24-17 · 2026-07-24 · Lähteet: RPX; CNIPA guidance; EPO family</a:t>
             </a:r>
           </a:p>
         </p:txBody>
@@ -4108,7 +4108,7 @@
         </p:nvSpPr>
         <p:spPr>
           <a:xfrm>
-            <a:off x="502920" y="1444752"/>
+            <a:off x="502920" y="1554480"/>
             <a:ext cx="960120" cy="50292"/>
           </a:xfrm>
           <a:prstGeom prst="rect">
@@ -4220,7 +4220,7 @@
                 </a:solidFill>
                 <a:latin typeface="Aptos"/>
               </a:rPr>
-              <a:t>Julkinen riippumaton evidenssikooste · 2026.07.23-16 · 2026-07-22 · Lähteet: IP Australia; PRH; EPO; EPO / UPC; USPTO</a:t>
+              <a:t>Julkinen riippumaton evidenssikooste · 2026.07.24-17 · 2026-07-24 · Lähteet: IP Australia; PRH; EPO; EPO / UPC; USPTO</a:t>
             </a:r>
           </a:p>
         </p:txBody>
@@ -4900,7 +4900,7 @@
                 </a:solidFill>
                 <a:latin typeface="Aptos"/>
               </a:rPr>
-              <a:t>Julkinen riippumaton evidenssikooste · 2026.07.23-16 · 2026-07-22 · Lähteet: UN; Atlas</a:t>
+              <a:t>Julkinen riippumaton evidenssikooste · 2026.07.24-17 · 2026-07-24 · Lähteet: UN; Atlas</a:t>
             </a:r>
           </a:p>
         </p:txBody>
@@ -5622,7 +5622,7 @@
         <p:spPr>
           <a:xfrm>
             <a:off x="502920" y="621792"/>
-            <a:ext cx="11109960" cy="548640"/>
+            <a:ext cx="11109960" cy="804672"/>
           </a:xfrm>
           <a:prstGeom prst="rect">
             <a:avLst/>
@@ -5637,13 +5637,13 @@
           <a:p>
             <a:pPr algn="l"/>
             <a:r>
-              <a:rPr sz="3400" b="1">
+              <a:rPr sz="3000" b="1">
                 <a:solidFill>
                   <a:srgbClr val="071A2B"/>
                 </a:solidFill>
                 <a:latin typeface="Aptos"/>
               </a:rPr>
-              <a:t>Viralliset havainnot 5 maasta mittaavat eri asioita</a:t>
+              <a:t>20 virallista havaintoa 6 maasta mittaavat eri asioita</a:t>
             </a:r>
           </a:p>
         </p:txBody>
@@ -5656,7 +5656,7 @@
         </p:nvSpPr>
         <p:spPr>
           <a:xfrm>
-            <a:off x="502920" y="1225296"/>
+            <a:off x="502920" y="1554480"/>
             <a:ext cx="960120" cy="50292"/>
           </a:xfrm>
           <a:prstGeom prst="rect">
@@ -5768,7 +5768,7 @@
                 </a:solidFill>
                 <a:latin typeface="Aptos"/>
               </a:rPr>
-              <a:t>Julkinen riippumaton evidenssikooste · 2026.07.23-16 · 2026-07-22 · Lähteet: Health Canada; Destatis; Vero; Sejm; Ruotsin hallitus</a:t>
+              <a:t>Julkinen riippumaton evidenssikooste · 2026.07.24-17 · 2026-07-24 · Lähteet: Health Canada; New Zealand Ministry of Health; Destatis; Vero; Sejm; Ruotsin hallitus</a:t>
             </a:r>
           </a:p>
         </p:txBody>
@@ -5817,8 +5817,8 @@
           <p:nvPr/>
         </p:nvGraphicFramePr>
         <p:xfrm>
-          <a:off x="530352" y="1536192"/>
-          <a:ext cx="11109960" cy="3977637"/>
+          <a:off x="530352" y="1719072"/>
+          <a:ext cx="11109960" cy="3794760"/>
         </p:xfrm>
         <a:graphic>
           <a:graphicData uri="http://schemas.openxmlformats.org/drawingml/2006/table">
@@ -5905,7 +5905,7 @@
                   </a:tcPr>
                 </a:tc>
               </a:tr>
-              <a:tr h="707745">
+              <a:tr h="559308">
                 <a:tc>
                   <a:txBody>
                     <a:bodyPr/>
@@ -5979,7 +5979,7 @@
                   </a:tcPr>
                 </a:tc>
               </a:tr>
-              <a:tr h="707745">
+              <a:tr h="559308">
                 <a:tc>
                   <a:txBody>
                     <a:bodyPr/>
@@ -6053,7 +6053,7 @@
                   </a:tcPr>
                 </a:tc>
               </a:tr>
-              <a:tr h="707745">
+              <a:tr h="559308">
                 <a:tc>
                   <a:txBody>
                     <a:bodyPr/>
@@ -6127,7 +6127,7 @@
                   </a:tcPr>
                 </a:tc>
               </a:tr>
-              <a:tr h="707745">
+              <a:tr h="559308">
                 <a:tc>
                   <a:txBody>
                     <a:bodyPr/>
@@ -6142,7 +6142,7 @@
                         </a:defRPr>
                       </a:pPr>
                       <a:r>
-                        <a:t>Puola</a:t>
+                        <a:t>Uusi-Seelanti</a:t>
                       </a:r>
                     </a:p>
                   </a:txBody>
@@ -6166,7 +6166,7 @@
                         </a:defRPr>
                       </a:pPr>
                       <a:r>
-                        <a:t>2023 / 2025</a:t>
+                        <a:t>2022–2024</a:t>
                       </a:r>
                     </a:p>
                   </a:txBody>
@@ -6190,7 +6190,7 @@
                         </a:defRPr>
                       </a:pPr>
                       <a:r>
-                        <a:t>805 441 l; 993,1 milj. PLN valmisteveroa</a:t>
+                        <a:t>otsikko vähintään 280 milj. NZD; 280,685 milj. NZD 29 tiedoston raakasumma; 264,561 milj. NZD toistorivien poistamisen herkkyys, ei korjattu estimaatti</a:t>
                       </a:r>
                     </a:p>
                   </a:txBody>
@@ -6201,7 +6201,7 @@
                   </a:tcPr>
                 </a:tc>
               </a:tr>
-              <a:tr h="707745">
+              <a:tr h="559308">
                 <a:tc>
                   <a:txBody>
                     <a:bodyPr/>
@@ -6216,7 +6216,7 @@
                         </a:defRPr>
                       </a:pPr>
                       <a:r>
-                        <a:t>Ruotsi</a:t>
+                        <a:t>Puola</a:t>
                       </a:r>
                     </a:p>
                   </a:txBody>
@@ -6240,7 +6240,7 @@
                         </a:defRPr>
                       </a:pPr>
                       <a:r>
-                        <a:t>2024</a:t>
+                        <a:t>2023 / 2025</a:t>
                       </a:r>
                     </a:p>
                   </a:txBody>
@@ -6264,13 +6264,87 @@
                         </a:defRPr>
                       </a:pPr>
                       <a:r>
+                        <a:t>805 441 l; 993,1 milj. PLN valmisteveroa</a:t>
+                      </a:r>
+                    </a:p>
+                  </a:txBody>
+                  <a:tcPr marL="73152" marR="73152" marT="36576" marB="36576">
+                    <a:solidFill>
+                      <a:srgbClr val="FFFFFF"/>
+                    </a:solidFill>
+                  </a:tcPr>
+                </a:tc>
+              </a:tr>
+              <a:tr h="559308">
+                <a:tc>
+                  <a:txBody>
+                    <a:bodyPr/>
+                    <a:lstStyle/>
+                    <a:p>
+                      <a:pPr algn="l">
+                        <a:defRPr sz="1320">
+                          <a:solidFill>
+                            <a:srgbClr val="182935"/>
+                          </a:solidFill>
+                          <a:latin typeface="Aptos"/>
+                        </a:defRPr>
+                      </a:pPr>
+                      <a:r>
+                        <a:t>Ruotsi</a:t>
+                      </a:r>
+                    </a:p>
+                  </a:txBody>
+                  <a:tcPr marL="73152" marR="73152" marT="36576" marB="36576">
+                    <a:solidFill>
+                      <a:srgbClr val="F6F9FA"/>
+                    </a:solidFill>
+                  </a:tcPr>
+                </a:tc>
+                <a:tc>
+                  <a:txBody>
+                    <a:bodyPr/>
+                    <a:lstStyle/>
+                    <a:p>
+                      <a:pPr algn="l">
+                        <a:defRPr sz="1320">
+                          <a:solidFill>
+                            <a:srgbClr val="182935"/>
+                          </a:solidFill>
+                          <a:latin typeface="Aptos"/>
+                        </a:defRPr>
+                      </a:pPr>
+                      <a:r>
+                        <a:t>2024</a:t>
+                      </a:r>
+                    </a:p>
+                  </a:txBody>
+                  <a:tcPr marL="73152" marR="73152" marT="36576" marB="36576">
+                    <a:solidFill>
+                      <a:srgbClr val="F6F9FA"/>
+                    </a:solidFill>
+                  </a:tcPr>
+                </a:tc>
+                <a:tc>
+                  <a:txBody>
+                    <a:bodyPr/>
+                    <a:lstStyle/>
+                    <a:p>
+                      <a:pPr algn="l">
+                        <a:defRPr sz="1320">
+                          <a:solidFill>
+                            <a:srgbClr val="182935"/>
+                          </a:solidFill>
+                          <a:latin typeface="Aptos"/>
+                        </a:defRPr>
+                      </a:pPr>
+                      <a:r>
                         <a:t>26 000 l; 80 milj. SEK valmisteveroa</a:t>
                       </a:r>
                     </a:p>
                   </a:txBody>
                   <a:tcPr marL="73152" marR="73152" marT="36576" marB="36576">
                     <a:solidFill>
-                      <a:srgbClr val="FFFFFF"/>
+                      <a:srgbClr val="F6F9FA"/>
                     </a:solidFill>
                   </a:tcPr>
                 </a:tc>
@@ -6522,7 +6596,7 @@
                 </a:solidFill>
                 <a:latin typeface="Aptos"/>
               </a:rPr>
-              <a:t>Julkinen riippumaton evidenssikooste · 2026.07.23-16 · 2026-07-22 · Lähteet: Health Canada 2024</a:t>
+              <a:t>Julkinen riippumaton evidenssikooste · 2026.07.24-17 · 2026-07-24 · Lähteet: Health Canada 2024</a:t>
             </a:r>
           </a:p>
         </p:txBody>
@@ -7161,7 +7235,7 @@
         </p:nvSpPr>
         <p:spPr>
           <a:xfrm>
-            <a:off x="502920" y="1444752"/>
+            <a:off x="502920" y="1554480"/>
             <a:ext cx="960120" cy="50292"/>
           </a:xfrm>
           <a:prstGeom prst="rect">
@@ -7273,7 +7347,7 @@
                 </a:solidFill>
                 <a:latin typeface="Aptos"/>
               </a:rPr>
-              <a:t>Julkinen riippumaton evidenssikooste · 2026.07.23-16 · 2026-07-22 · Lähteet: Destatis</a:t>
+              <a:t>Julkinen riippumaton evidenssikooste · 2026.07.24-17 · 2026-07-24 · Lähteet: Destatis</a:t>
             </a:r>
           </a:p>
         </p:txBody>
@@ -7976,7 +8050,7 @@
                 </a:solidFill>
                 <a:latin typeface="Aptos"/>
               </a:rPr>
-              <a:t>Julkinen riippumaton evidenssikooste · 2026.07.23-16 · 2026-07-22 · Lähteet: Destatis; inTaste.de</a:t>
+              <a:t>Julkinen riippumaton evidenssikooste · 2026.07.24-17 · 2026-07-24 · Lähteet: Destatis; inTaste.de</a:t>
             </a:r>
           </a:p>
         </p:txBody>
@@ -8727,7 +8801,7 @@
                 </a:solidFill>
                 <a:latin typeface="Aptos"/>
               </a:rPr>
-              <a:t>Julkinen riippumaton evidenssikooste · 2026.07.23-16 · 2026-07-22 · Lähteet: IMARC; GVR; Fortune</a:t>
+              <a:t>Julkinen riippumaton evidenssikooste · 2026.07.24-17 · 2026-07-24 · Lähteet: IMARC; GVR; Fortune; European Commission</a:t>
             </a:r>
           </a:p>
         </p:txBody>
@@ -8776,7 +8850,7 @@
         <p:spPr>
           <a:xfrm>
             <a:off x="530352" y="1719072"/>
-            <a:ext cx="3532632" cy="1371600"/>
+            <a:ext cx="2585466" cy="1371600"/>
           </a:xfrm>
           <a:prstGeom prst="roundRect">
             <a:avLst>
@@ -8823,7 +8897,7 @@
         <p:spPr>
           <a:xfrm>
             <a:off x="694944" y="1883664"/>
-            <a:ext cx="3203448" cy="530352"/>
+            <a:ext cx="2256282" cy="530352"/>
           </a:xfrm>
           <a:prstGeom prst="rect">
             <a:avLst/>
@@ -8858,7 +8932,7 @@
         <p:spPr>
           <a:xfrm>
             <a:off x="694944" y="2468879"/>
-            <a:ext cx="3203448" cy="438912"/>
+            <a:ext cx="2256282" cy="438912"/>
           </a:xfrm>
           <a:prstGeom prst="rect">
             <a:avLst/>
@@ -8892,8 +8966,8 @@
         </p:nvSpPr>
         <p:spPr>
           <a:xfrm>
-            <a:off x="4319016" y="1719072"/>
-            <a:ext cx="3532632" cy="1371600"/>
+            <a:off x="3371850" y="1719072"/>
+            <a:ext cx="2585466" cy="1371600"/>
           </a:xfrm>
           <a:prstGeom prst="roundRect">
             <a:avLst>
@@ -8939,8 +9013,8 @@
         </p:nvSpPr>
         <p:spPr>
           <a:xfrm>
-            <a:off x="4483608" y="1883664"/>
-            <a:ext cx="3203448" cy="530352"/>
+            <a:off x="3536442" y="1883664"/>
+            <a:ext cx="2256282" cy="530352"/>
           </a:xfrm>
           <a:prstGeom prst="rect">
             <a:avLst/>
@@ -8974,8 +9048,8 @@
         </p:nvSpPr>
         <p:spPr>
           <a:xfrm>
-            <a:off x="4483608" y="2468879"/>
-            <a:ext cx="3203448" cy="438912"/>
+            <a:off x="3536442" y="2468879"/>
+            <a:ext cx="2256282" cy="438912"/>
           </a:xfrm>
           <a:prstGeom prst="rect">
             <a:avLst/>
@@ -9009,8 +9083,8 @@
         </p:nvSpPr>
         <p:spPr>
           <a:xfrm>
-            <a:off x="8107680" y="1719072"/>
-            <a:ext cx="3532632" cy="1371600"/>
+            <a:off x="6213348" y="1719072"/>
+            <a:ext cx="2585466" cy="1371600"/>
           </a:xfrm>
           <a:prstGeom prst="roundRect">
             <a:avLst>
@@ -9056,8 +9130,8 @@
         </p:nvSpPr>
         <p:spPr>
           <a:xfrm>
-            <a:off x="8272272" y="1883664"/>
-            <a:ext cx="3203448" cy="530352"/>
+            <a:off x="6377940" y="1883664"/>
+            <a:ext cx="2256282" cy="530352"/>
           </a:xfrm>
           <a:prstGeom prst="rect">
             <a:avLst/>
@@ -9091,8 +9165,8 @@
         </p:nvSpPr>
         <p:spPr>
           <a:xfrm>
-            <a:off x="8272272" y="2468879"/>
-            <a:ext cx="3203448" cy="438912"/>
+            <a:off x="6377940" y="2468879"/>
+            <a:ext cx="2256282" cy="438912"/>
           </a:xfrm>
           <a:prstGeom prst="rect">
             <a:avLst/>
@@ -9120,7 +9194,124 @@
       </p:sp>
       <p:sp>
         <p:nvSpPr>
-          <p:cNvPr id="17" name="TextBox 16"/>
+          <p:cNvPr id="17" name="Rounded Rectangle 16"/>
+          <p:cNvSpPr/>
+          <p:nvPr/>
+        </p:nvSpPr>
+        <p:spPr>
+          <a:xfrm>
+            <a:off x="9054846" y="1719072"/>
+            <a:ext cx="2585466" cy="1371600"/>
+          </a:xfrm>
+          <a:prstGeom prst="roundRect">
+            <a:avLst>
+              <a:gd name="adj" fmla="val 8000"/>
+            </a:avLst>
+          </a:prstGeom>
+          <a:solidFill>
+            <a:srgbClr val="F6F9FA"/>
+          </a:solidFill>
+          <a:ln>
+            <a:solidFill>
+              <a:srgbClr val="CBD8DE"/>
+            </a:solidFill>
+          </a:ln>
+        </p:spPr>
+        <p:style>
+          <a:lnRef idx="1">
+            <a:schemeClr val="accent1"/>
+          </a:lnRef>
+          <a:fillRef idx="3">
+            <a:schemeClr val="accent1"/>
+          </a:fillRef>
+          <a:effectRef idx="2">
+            <a:schemeClr val="accent1"/>
+          </a:effectRef>
+          <a:fontRef idx="minor">
+            <a:schemeClr val="lt1"/>
+          </a:fontRef>
+        </p:style>
+        <p:txBody>
+          <a:bodyPr rtlCol="0" anchor="ctr"/>
+          <a:lstStyle/>
+          <a:p>
+            <a:pPr algn="ctr"/>
+          </a:p>
+        </p:txBody>
+      </p:sp>
+      <p:sp>
+        <p:nvSpPr>
+          <p:cNvPr id="18" name="TextBox 17"/>
+          <p:cNvSpPr txBox="1"/>
+          <p:nvPr/>
+        </p:nvSpPr>
+        <p:spPr>
+          <a:xfrm>
+            <a:off x="9219438" y="1883664"/>
+            <a:ext cx="2256282" cy="530352"/>
+          </a:xfrm>
+          <a:prstGeom prst="rect">
+            <a:avLst/>
+          </a:prstGeom>
+          <a:noFill/>
+        </p:spPr>
+        <p:txBody>
+          <a:bodyPr wrap="square" lIns="36576" rIns="36576" tIns="36576" bIns="36576" anchor="t">
+            <a:spAutoFit/>
+          </a:bodyPr>
+          <a:lstStyle/>
+          <a:p>
+            <a:pPr algn="l"/>
+            <a:r>
+              <a:rPr sz="2700" b="1">
+                <a:solidFill>
+                  <a:srgbClr val="138A72"/>
+                </a:solidFill>
+                <a:latin typeface="Aptos"/>
+              </a:rPr>
+              <a:t>4,99 mrd EUR</a:t>
+            </a:r>
+          </a:p>
+        </p:txBody>
+      </p:sp>
+      <p:sp>
+        <p:nvSpPr>
+          <p:cNvPr id="19" name="TextBox 18"/>
+          <p:cNvSpPr txBox="1"/>
+          <p:nvPr/>
+        </p:nvSpPr>
+        <p:spPr>
+          <a:xfrm>
+            <a:off x="9219438" y="2468879"/>
+            <a:ext cx="2256282" cy="438912"/>
+          </a:xfrm>
+          <a:prstGeom prst="rect">
+            <a:avLst/>
+          </a:prstGeom>
+          <a:noFill/>
+        </p:spPr>
+        <p:txBody>
+          <a:bodyPr wrap="square" lIns="36576" rIns="36576" tIns="36576" bIns="36576" anchor="t">
+            <a:spAutoFit/>
+          </a:bodyPr>
+          <a:lstStyle/>
+          <a:p>
+            <a:pPr algn="l"/>
+            <a:r>
+              <a:rPr sz="1400" b="0">
+                <a:solidFill>
+                  <a:srgbClr val="5B6B75"/>
+                </a:solidFill>
+                <a:latin typeface="Aptos"/>
+              </a:rPr>
+              <a:t>EU-komission vertailuarvo 2023</a:t>
+            </a:r>
+          </a:p>
+        </p:txBody>
+      </p:sp>
+      <p:sp>
+        <p:nvSpPr>
+          <p:cNvPr id="20" name="TextBox 19"/>
           <p:cNvSpPr txBox="1"/>
           <p:nvPr/>
         </p:nvSpPr>
@@ -9148,14 +9339,14 @@
                 </a:solidFill>
                 <a:latin typeface="Aptos"/>
               </a:rPr>
-              <a:t>Haarukka on leveä, koska tuoterajaukset ja metodit voivat poiketa.</a:t>
-            </a:r>
-          </a:p>
-        </p:txBody>
-      </p:sp>
-      <p:sp>
-        <p:nvSpPr>
-          <p:cNvPr id="18" name="Rounded Rectangle 17"/>
+              <a:t>EU:n vertailuarvo tukee mittaluokan ristiintarkistusta; kaupallinen haarukka on leveä, koska tuoterajaukset ja metodit voivat poiketa.</a:t>
+            </a:r>
+          </a:p>
+        </p:txBody>
+      </p:sp>
+      <p:sp>
+        <p:nvSpPr>
+          <p:cNvPr id="21" name="Rounded Rectangle 20"/>
           <p:cNvSpPr/>
           <p:nvPr/>
         </p:nvSpPr>
@@ -9202,7 +9393,7 @@
       </p:sp>
       <p:sp>
         <p:nvSpPr>
-          <p:cNvPr id="19" name="TextBox 18"/>
+          <p:cNvPr id="22" name="TextBox 21"/>
           <p:cNvSpPr txBox="1"/>
           <p:nvPr/>
         </p:nvSpPr>
@@ -9237,7 +9428,7 @@
       </p:sp>
       <p:sp>
         <p:nvSpPr>
-          <p:cNvPr id="20" name="TextBox 19"/>
+          <p:cNvPr id="23" name="TextBox 22"/>
           <p:cNvSpPr txBox="1"/>
           <p:nvPr/>
         </p:nvSpPr>
@@ -9265,7 +9456,7 @@
                 </a:solidFill>
                 <a:latin typeface="Aptos"/>
               </a:rPr>
-              <a:t>Arvioita verrataan keskenään. Niitä ei summata, eikä haarukkaa käytetä automaattisesti rojaltipohjana.</a:t>
+              <a:t>EU-luku perustuu kaupalliseen Euromonitor 2025 -aineistoon; Kypros, Luxemburg ja Malta puuttuvat. Se ei ole kansallinen luovuttajamarkkina. Arvioita verrataan, ei summata tai käytetä automaattisesti rojaltipohjana.</a:t>
             </a:r>
           </a:p>
         </p:txBody>
@@ -9478,7 +9669,7 @@
                 </a:solidFill>
                 <a:latin typeface="Aptos"/>
               </a:rPr>
-              <a:t>Julkinen riippumaton evidenssikooste · 2026.07.23-16 · 2026-07-22 · Lähteet: Market-values modelReadiness</a:t>
+              <a:t>Julkinen riippumaton evidenssikooste · 2026.07.24-17 · 2026-07-24 · Lähteet: Market-values modelReadiness, donorProtocol ja donorCandidates</a:t>
             </a:r>
           </a:p>
         </p:txBody>
@@ -9548,7 +9739,7 @@
                 </a:solidFill>
                 <a:latin typeface="Aptos"/>
               </a:rPr>
-              <a:t>Nykyinen comparable consumer-retail donor count on 0; hard gate ei täyty.</a:t>
+              <a:t>Nykyinen hyväksytty donor-portti on 0/3; kaikki 4 ehdokasta jäivät ulkopuolelle.</a:t>
             </a:r>
           </a:p>
         </p:txBody>
@@ -9590,7 +9781,7 @@
               </a:defRPr>
             </a:pPr>
             <a:r>
-              <a:t>•  Sama tuoterajaus ja kalenterivuosi.</a:t>
+              <a:t>•  Jokaisen ehdokkaan on läpäistävä kaikki 10 ehtoa (D1–D10).</a:t>
             </a:r>
           </a:p>
           <a:p>
@@ -9609,7 +9800,7 @@
               </a:defRPr>
             </a:pPr>
             <a:r>
-              <a:t>•  Kuluttajavähittäisarvo, ei toimitus-, vero- tai volyymiproxy.</a:t>
+              <a:t>•  Uusi-Seelantin 280,685 milj. NZD raakasumma ja 264,561 milj. NZD toistoriviherkkyys eivät ole puhdistettu estimaatti; EU:n vertailuarvo, Kanadan toimitusproxy ja Saksan nestemalli hylättiin myös luovuttajina.</a:t>
             </a:r>
           </a:p>
           <a:p>
@@ -9628,7 +9819,7 @@
               </a:defRPr>
             </a:pPr>
             <a:r>
-              <a:t>•  Alue- ja sääntelytyyppien peitto sekä suora validointi suurissa talouksissa.</a:t>
+              <a:t>•  Alue- ja sääntelytyyppien peitto sekä suora validointi suurissa talouksissa vaaditaan vielä.</a:t>
             </a:r>
           </a:p>
         </p:txBody>
@@ -9846,7 +10037,7 @@
         </p:nvSpPr>
         <p:spPr>
           <a:xfrm>
-            <a:off x="502920" y="1444752"/>
+            <a:off x="502920" y="1554480"/>
             <a:ext cx="960120" cy="50292"/>
           </a:xfrm>
           <a:prstGeom prst="rect">
@@ -9958,7 +10149,7 @@
                 </a:solidFill>
                 <a:latin typeface="Aptos"/>
               </a:rPr>
-              <a:t>Julkinen riippumaton evidenssikooste · 2026.07.23-16 · 2026-07-22 · Lähteet: WIPO valuation; Evidence Register</a:t>
+              <a:t>Julkinen riippumaton evidenssikooste · 2026.07.24-17 · 2026-07-24 · Lähteet: WIPO valuation; Evidence Register</a:t>
             </a:r>
           </a:p>
         </p:txBody>
@@ -10712,7 +10903,7 @@
                 </a:solidFill>
                 <a:latin typeface="Aptos"/>
               </a:rPr>
-              <a:t>Julkinen riippumaton evidenssikooste · 2026.07.23-16 · 2026-07-22 · Lähteet: EPO; Saksa — viralliset tuomiot; WIPO</a:t>
+              <a:t>Julkinen riippumaton evidenssikooste · 2026.07.24-17 · 2026-07-24 · Lähteet: EPO; Saksa — viralliset tuomiot; WIPO</a:t>
             </a:r>
           </a:p>
         </p:txBody>
@@ -10843,7 +11034,7 @@
               </a:defRPr>
             </a:pPr>
             <a:r>
-              <a:t>•  Markkina-aineisto kattaa 195 maan tutkimusrungon, mutta yhteismitallisia retail-luovuttajia on 0.</a:t>
+              <a:t>•  Markkina-aineistossa on 20 virallista vuosihavaintoa 6 maasta, mutta luovuttajaportti on 0/3.</a:t>
             </a:r>
           </a:p>
           <a:p>
@@ -11192,7 +11383,7 @@
                 </a:solidFill>
                 <a:latin typeface="Aptos"/>
               </a:rPr>
-              <a:t>Julkinen riippumaton evidenssikooste · 2026.07.23-16 · 2026-07-22 · Lähteet: WIPO licensing; IP Finance</a:t>
+              <a:t>Julkinen riippumaton evidenssikooste · 2026.07.24-17 · 2026-07-24 · Lähteet: WIPO licensing; IP Finance</a:t>
             </a:r>
           </a:p>
         </p:txBody>
@@ -11560,7 +11751,7 @@
         </p:nvSpPr>
         <p:spPr>
           <a:xfrm>
-            <a:off x="502920" y="1444752"/>
+            <a:off x="502920" y="1554480"/>
             <a:ext cx="960120" cy="50292"/>
           </a:xfrm>
           <a:prstGeom prst="rect">
@@ -11672,7 +11863,7 @@
                 </a:solidFill>
                 <a:latin typeface="Aptos"/>
               </a:rPr>
-              <a:t>Julkinen riippumaton evidenssikooste · 2026.07.23-16 · 2026-07-22 · Lähteet: Evidence Register; EPO</a:t>
+              <a:t>Julkinen riippumaton evidenssikooste · 2026.07.24-17 · 2026-07-24 · Lähteet: Evidence Register; EPO</a:t>
             </a:r>
           </a:p>
         </p:txBody>
@@ -12352,7 +12543,7 @@
                 </a:solidFill>
                 <a:latin typeface="Aptos"/>
               </a:rPr>
-              <a:t>Julkinen riippumaton evidenssikooste · 2026.07.23-16 · 2026-07-22 · Lähteet: EP3032975B2; 7 O 3341/24</a:t>
+              <a:t>Julkinen riippumaton evidenssikooste · 2026.07.24-17 · 2026-07-24 · Lähteet: EP3032975B2; 7 O 3341/24</a:t>
             </a:r>
           </a:p>
         </p:txBody>
@@ -13243,7 +13434,7 @@
                 </a:solidFill>
                 <a:latin typeface="Aptos"/>
               </a:rPr>
-              <a:t>Julkinen riippumaton evidenssikooste · 2026.07.23-16 · 2026-07-22 · Lähteet: WIPO dispute resolution; EPO IPscore</a:t>
+              <a:t>Julkinen riippumaton evidenssikooste · 2026.07.24-17 · 2026-07-24 · Lähteet: WIPO dispute resolution; EPO IPscore</a:t>
             </a:r>
           </a:p>
         </p:txBody>
@@ -14022,7 +14213,7 @@
         </p:nvSpPr>
         <p:spPr>
           <a:xfrm>
-            <a:off x="502920" y="1444752"/>
+            <a:off x="502920" y="1554480"/>
             <a:ext cx="960120" cy="50292"/>
           </a:xfrm>
           <a:prstGeom prst="rect">
@@ -14134,7 +14325,7 @@
                 </a:solidFill>
                 <a:latin typeface="Aptos"/>
               </a:rPr>
-              <a:t>Julkinen riippumaton evidenssikooste · 2026.07.23-16 · 2026-07-22 · Lähteet: WIPO licensing; IP Finance; TPLF mapping</a:t>
+              <a:t>Julkinen riippumaton evidenssikooste · 2026.07.24-17 · 2026-07-24 · Lähteet: WIPO licensing; IP Finance; TPLF mapping</a:t>
             </a:r>
           </a:p>
         </p:txBody>
@@ -14888,7 +15079,7 @@
                 </a:solidFill>
                 <a:latin typeface="Aptos"/>
               </a:rPr>
-              <a:t>Julkinen riippumaton evidenssikooste · 2026.07.23-16 · 2026-07-22 · Lähteet: Evidence Register; WIPO valuation</a:t>
+              <a:t>Julkinen riippumaton evidenssikooste · 2026.07.24-17 · 2026-07-24 · Lähteet: Evidence Register; WIPO valuation</a:t>
             </a:r>
           </a:p>
         </p:txBody>
@@ -15716,7 +15907,7 @@
                 </a:solidFill>
                 <a:latin typeface="Aptos"/>
               </a:rPr>
-              <a:t>Julkinen riippumaton evidenssikooste · 2026.07.23-16 · 2026-07-22 · Lähteet: WIPO valuation</a:t>
+              <a:t>Julkinen riippumaton evidenssikooste · 2026.07.24-17 · 2026-07-24 · Lähteet: WIPO valuation</a:t>
             </a:r>
           </a:p>
         </p:txBody>
@@ -16503,7 +16694,7 @@
         </p:nvSpPr>
         <p:spPr>
           <a:xfrm>
-            <a:off x="502920" y="1444752"/>
+            <a:off x="502920" y="1554480"/>
             <a:ext cx="960120" cy="50292"/>
           </a:xfrm>
           <a:prstGeom prst="rect">
@@ -16615,7 +16806,7 @@
                 </a:solidFill>
                 <a:latin typeface="Aptos"/>
               </a:rPr>
-              <a:t>Julkinen riippumaton evidenssikooste · 2026.07.23-16 · 2026-07-22 · Lähteet: Evidence Register</a:t>
+              <a:t>Julkinen riippumaton evidenssikooste · 2026.07.24-17 · 2026-07-24 · Lähteet: Evidence Register</a:t>
             </a:r>
           </a:p>
         </p:txBody>
@@ -17257,7 +17448,7 @@
         </p:nvSpPr>
         <p:spPr>
           <a:xfrm>
-            <a:off x="502920" y="1444752"/>
+            <a:off x="502920" y="1554480"/>
             <a:ext cx="960120" cy="50292"/>
           </a:xfrm>
           <a:prstGeom prst="rect">
@@ -17369,7 +17560,7 @@
                 </a:solidFill>
                 <a:latin typeface="Aptos"/>
               </a:rPr>
-              <a:t>Julkinen riippumaton evidenssikooste · 2026.07.23-16 · 2026-07-22 · Lähteet: Evidence Register</a:t>
+              <a:t>Julkinen riippumaton evidenssikooste · 2026.07.24-17 · 2026-07-24 · Lähteet: Evidence Register</a:t>
             </a:r>
           </a:p>
         </p:txBody>
@@ -18197,7 +18388,7 @@
                 </a:solidFill>
                 <a:latin typeface="Aptos"/>
               </a:rPr>
-              <a:t>Julkinen riippumaton evidenssikooste · 2026.07.23-16 · 2026-07-22 · Lähteet: Evidence Register; changelog</a:t>
+              <a:t>Julkinen riippumaton evidenssikooste · 2026.07.24-17 · 2026-07-24 · Lähteet: Evidence Register; changelog</a:t>
             </a:r>
           </a:p>
         </p:txBody>
@@ -18976,7 +19167,7 @@
         </p:nvSpPr>
         <p:spPr>
           <a:xfrm>
-            <a:off x="502920" y="1444752"/>
+            <a:off x="502920" y="1554480"/>
             <a:ext cx="960120" cy="50292"/>
           </a:xfrm>
           <a:prstGeom prst="rect">
@@ -19088,7 +19279,7 @@
                 </a:solidFill>
                 <a:latin typeface="Aptos"/>
               </a:rPr>
-              <a:t>Julkinen riippumaton evidenssikooste · 2026.07.23-16 · 2026-07-22 · Lähteet: EPO; 8 Ni 18/24 (EP); 7 O 3341/24</a:t>
+              <a:t>Julkinen riippumaton evidenssikooste · 2026.07.24-17 · 2026-07-24 · Lähteet: EPO; 8 Ni 18/24 (EP); 7 O 3341/24</a:t>
             </a:r>
           </a:p>
         </p:txBody>
@@ -19711,7 +19902,7 @@
                 </a:solidFill>
                 <a:latin typeface="Aptos"/>
               </a:rPr>
-              <a:t>Versio 2026.07.23-16 · 2026-07-22 · 30 / 30</a:t>
+              <a:t>Versio 2026.07.24-17 · 2026-07-24 · 30 / 30</a:t>
             </a:r>
           </a:p>
         </p:txBody>
@@ -19924,7 +20115,7 @@
                 </a:solidFill>
                 <a:latin typeface="Aptos"/>
               </a:rPr>
-              <a:t>Julkinen riippumaton evidenssikooste · 2026.07.23-16 · 2026-07-22 · Lähteet: Evidence Register; WIPO</a:t>
+              <a:t>Julkinen riippumaton evidenssikooste · 2026.07.24-17 · 2026-07-24 · Lähteet: Evidence Register; WIPO</a:t>
             </a:r>
           </a:p>
         </p:txBody>
@@ -20404,7 +20595,7 @@
                 </a:solidFill>
                 <a:latin typeface="Aptos"/>
               </a:rPr>
-              <a:t>Julkinen riippumaton evidenssikooste · 2026.07.23-16 · 2026-07-22 · Lähteet: EP3032975B2</a:t>
+              <a:t>Julkinen riippumaton evidenssikooste · 2026.07.24-17 · 2026-07-24 · Lähteet: EP3032975B2</a:t>
             </a:r>
           </a:p>
         </p:txBody>
@@ -20772,7 +20963,7 @@
         </p:nvSpPr>
         <p:spPr>
           <a:xfrm>
-            <a:off x="502920" y="1444752"/>
+            <a:off x="502920" y="1554480"/>
             <a:ext cx="960120" cy="50292"/>
           </a:xfrm>
           <a:prstGeom prst="rect">
@@ -20884,7 +21075,7 @@
                 </a:solidFill>
                 <a:latin typeface="Aptos"/>
               </a:rPr>
-              <a:t>Julkinen riippumaton evidenssikooste · 2026.07.23-16 · 2026-07-22 · Lähteet: EP3032975B2</a:t>
+              <a:t>Julkinen riippumaton evidenssikooste · 2026.07.24-17 · 2026-07-24 · Lähteet: EP3032975B2</a:t>
             </a:r>
           </a:p>
         </p:txBody>
@@ -21638,7 +21829,7 @@
                 </a:solidFill>
                 <a:latin typeface="Aptos"/>
               </a:rPr>
-              <a:t>Julkinen riippumaton evidenssikooste · 2026.07.23-16 · 2026-07-22 · Lähteet: EPO Register; B2</a:t>
+              <a:t>Julkinen riippumaton evidenssikooste · 2026.07.24-17 · 2026-07-24 · Lähteet: EPO Register; B2</a:t>
             </a:r>
           </a:p>
         </p:txBody>
@@ -22389,7 +22580,7 @@
                 </a:solidFill>
                 <a:latin typeface="Aptos"/>
               </a:rPr>
-              <a:t>Julkinen riippumaton evidenssikooste · 2026.07.23-16 · 2026-07-22 · Lähteet: EPO family; kansalliset rekisterit</a:t>
+              <a:t>Julkinen riippumaton evidenssikooste · 2026.07.24-17 · 2026-07-24 · Lähteet: EPO family; kansalliset rekisterit</a:t>
             </a:r>
           </a:p>
         </p:txBody>
@@ -23145,7 +23336,7 @@
         </p:nvSpPr>
         <p:spPr>
           <a:xfrm>
-            <a:off x="502920" y="1444752"/>
+            <a:off x="502920" y="1554480"/>
             <a:ext cx="960120" cy="50292"/>
           </a:xfrm>
           <a:prstGeom prst="rect">
@@ -23257,7 +23448,7 @@
                 </a:solidFill>
                 <a:latin typeface="Aptos"/>
               </a:rPr>
-              <a:t>Julkinen riippumaton evidenssikooste · 2026.07.23-16 · 2026-07-22 · Lähteet: Viralliset tuomiot: 8 Ni 18/24 (EP); 7 O 3341/24</a:t>
+              <a:t>Julkinen riippumaton evidenssikooste · 2026.07.24-17 · 2026-07-24 · Lähteet: Viralliset tuomiot: 8 Ni 18/24 (EP); 7 O 3341/24</a:t>
             </a:r>
           </a:p>
         </p:txBody>

</xml_diff>